<commit_message>
Enhance presentation: 15 slides matching Canva Tech Vibrant Trendy theme
</commit_message>
<xml_diff>
--- a/Role_Based_Chatbot_Presentation.pptx
+++ b/Role_Based_Chatbot_Presentation.pptx
@@ -14,6 +14,12 @@
     <p:sldId id="262" r:id="rId13"/>
     <p:sldId id="263" r:id="rId14"/>
     <p:sldId id="264" r:id="rId15"/>
+    <p:sldId id="265" r:id="rId16"/>
+    <p:sldId id="266" r:id="rId17"/>
+    <p:sldId id="267" r:id="rId18"/>
+    <p:sldId id="268" r:id="rId19"/>
+    <p:sldId id="269" r:id="rId20"/>
+    <p:sldId id="270" r:id="rId21"/>
   </p:sldIdLst>
   <p:sldSz cx="9144000" cy="6858000" type="screen4x3"/>
   <p:notesSz cx="6858000" cy="9144000"/>
@@ -3154,7 +3160,7 @@
             <a:avLst/>
           </a:prstGeom>
           <a:solidFill>
-            <a:srgbClr val="4361EE"/>
+            <a:srgbClr val="5856D6"/>
           </a:solidFill>
           <a:ln>
             <a:noFill/>
@@ -3283,14 +3289,14 @@
           <a:lstStyle/>
           <a:p>
             <a:pPr algn="ctr">
-              <a:defRPr sz="3200" b="1">
+              <a:defRPr sz="2800" b="1">
                 <a:solidFill>
                   <a:srgbClr val="3AFFD9"/>
                 </a:solidFill>
               </a:defRPr>
             </a:pPr>
             <a:r>
-              <a:t>AI-POWERED SEMANTIC SEARCH</a:t>
+              <a:t>AI-POWERED</a:t>
             </a:r>
           </a:p>
           <a:p>
@@ -3302,7 +3308,7 @@
               </a:defRPr>
             </a:pPr>
             <a:r>
-              <a:t>WITH RAG PIPELINE &amp; RBAC SECURITY</a:t>
+              <a:t>SEMANTIC SEARCH FOR COMPANY DOCUMENTS</a:t>
             </a:r>
           </a:p>
         </p:txBody>
@@ -3315,8 +3321,8 @@
         </p:nvSpPr>
         <p:spPr>
           <a:xfrm>
-            <a:off x="914400" y="5029200"/>
-            <a:ext cx="7315200" cy="731520"/>
+            <a:off x="914400" y="5303520"/>
+            <a:ext cx="7315200" cy="914400"/>
           </a:xfrm>
           <a:prstGeom prst="rect">
             <a:avLst/>
@@ -3328,16 +3334,3629 @@
             <a:spAutoFit/>
           </a:bodyPr>
           <a:lstStyle/>
+          <a:p>
+            <a:pPr algn="ctr">
+              <a:defRPr sz="2000" b="1">
+                <a:solidFill>
+                  <a:srgbClr val="3AFFD9"/>
+                </a:solidFill>
+              </a:defRPr>
+            </a:pPr>
+            <a:r>
+              <a:t>THYNK UNLIMITED</a:t>
+            </a:r>
+          </a:p>
           <a:p>
             <a:pPr algn="ctr">
               <a:defRPr sz="1400">
                 <a:solidFill>
+                  <a:srgbClr val="FFFFFF"/>
+                </a:solidFill>
+              </a:defRPr>
+            </a:pPr>
+            <a:r>
+              <a:t>WE LEARN FOR THE FUTURE</a:t>
+            </a:r>
+          </a:p>
+        </p:txBody>
+      </p:sp>
+    </p:spTree>
+  </p:cSld>
+  <p:clrMapOvr>
+    <a:masterClrMapping/>
+  </p:clrMapOvr>
+</p:sld>
+</file>
+
+<file path=ppt/slides/slide10.xml><?xml version="1.0" encoding="utf-8"?>
+<p:sld xmlns:a="http://schemas.openxmlformats.org/drawingml/2006/main" xmlns:p="http://schemas.openxmlformats.org/presentationml/2006/main" xmlns:r="http://schemas.openxmlformats.org/officeDocument/2006/relationships">
+  <p:cSld>
+    <p:spTree>
+      <p:nvGrpSpPr>
+        <p:cNvPr id="1" name=""/>
+        <p:cNvGrpSpPr/>
+        <p:nvPr/>
+      </p:nvGrpSpPr>
+      <p:grpSpPr/>
+      <p:sp>
+        <p:nvSpPr>
+          <p:cNvPr id="2" name="Rectangle 1"/>
+          <p:cNvSpPr/>
+          <p:nvPr/>
+        </p:nvSpPr>
+        <p:spPr>
+          <a:xfrm>
+            <a:off x="0" y="0"/>
+            <a:ext cx="9144000" cy="6858000"/>
+          </a:xfrm>
+          <a:prstGeom prst="rect">
+            <a:avLst/>
+          </a:prstGeom>
+          <a:solidFill>
+            <a:srgbClr val="F8FAFC"/>
+          </a:solidFill>
+          <a:ln>
+            <a:noFill/>
+          </a:ln>
+        </p:spPr>
+        <p:style>
+          <a:lnRef idx="1">
+            <a:schemeClr val="accent1"/>
+          </a:lnRef>
+          <a:fillRef idx="3">
+            <a:schemeClr val="accent1"/>
+          </a:fillRef>
+          <a:effectRef idx="2">
+            <a:schemeClr val="accent1"/>
+          </a:effectRef>
+          <a:fontRef idx="minor">
+            <a:schemeClr val="lt1"/>
+          </a:fontRef>
+        </p:style>
+        <p:txBody>
+          <a:bodyPr rtlCol="0" anchor="ctr"/>
+          <a:lstStyle/>
+          <a:p>
+            <a:pPr algn="ctr"/>
+          </a:p>
+        </p:txBody>
+      </p:sp>
+      <p:sp>
+        <p:nvSpPr>
+          <p:cNvPr id="3" name="TextBox 2"/>
+          <p:cNvSpPr txBox="1"/>
+          <p:nvPr/>
+        </p:nvSpPr>
+        <p:spPr>
+          <a:xfrm>
+            <a:off x="914400" y="457200"/>
+            <a:ext cx="7315200" cy="731520"/>
+          </a:xfrm>
+          <a:prstGeom prst="rect">
+            <a:avLst/>
+          </a:prstGeom>
+          <a:noFill/>
+        </p:spPr>
+        <p:txBody>
+          <a:bodyPr wrap="none">
+            <a:spAutoFit/>
+          </a:bodyPr>
+          <a:lstStyle/>
+          <a:p>
+            <a:pPr algn="ctr">
+              <a:defRPr sz="3600" b="1">
+                <a:solidFill>
+                  <a:srgbClr val="FF4785"/>
+                </a:solidFill>
+              </a:defRPr>
+            </a:pPr>
+            <a:r>
+              <a:t>SECURITY FEATURES</a:t>
+            </a:r>
+          </a:p>
+        </p:txBody>
+      </p:sp>
+      <p:sp>
+        <p:nvSpPr>
+          <p:cNvPr id="4" name="Rounded Rectangle 3"/>
+          <p:cNvSpPr/>
+          <p:nvPr/>
+        </p:nvSpPr>
+        <p:spPr>
+          <a:xfrm>
+            <a:off x="1371600" y="1645920"/>
+            <a:ext cx="6400800" cy="777240"/>
+          </a:xfrm>
+          <a:prstGeom prst="roundRect">
+            <a:avLst/>
+          </a:prstGeom>
+          <a:solidFill>
+            <a:srgbClr val="FFFFFF"/>
+          </a:solidFill>
+          <a:ln w="38100">
+            <a:solidFill>
+              <a:srgbClr val="5856D6"/>
+            </a:solidFill>
+          </a:ln>
+        </p:spPr>
+        <p:style>
+          <a:lnRef idx="1">
+            <a:schemeClr val="accent1"/>
+          </a:lnRef>
+          <a:fillRef idx="3">
+            <a:schemeClr val="accent1"/>
+          </a:fillRef>
+          <a:effectRef idx="2">
+            <a:schemeClr val="accent1"/>
+          </a:effectRef>
+          <a:fontRef idx="minor">
+            <a:schemeClr val="lt1"/>
+          </a:fontRef>
+        </p:style>
+        <p:txBody>
+          <a:bodyPr rtlCol="0" anchor="ctr"/>
+          <a:lstStyle/>
+          <a:p>
+            <a:pPr algn="ctr"/>
+          </a:p>
+        </p:txBody>
+      </p:sp>
+      <p:sp>
+        <p:nvSpPr>
+          <p:cNvPr id="5" name="TextBox 4"/>
+          <p:cNvSpPr txBox="1"/>
+          <p:nvPr/>
+        </p:nvSpPr>
+        <p:spPr>
+          <a:xfrm>
+            <a:off x="1828800" y="1783080"/>
+            <a:ext cx="2743200" cy="274320"/>
+          </a:xfrm>
+          <a:prstGeom prst="rect">
+            <a:avLst/>
+          </a:prstGeom>
+          <a:noFill/>
+        </p:spPr>
+        <p:txBody>
+          <a:bodyPr wrap="none">
+            <a:spAutoFit/>
+          </a:bodyPr>
+          <a:lstStyle/>
+          <a:p>
+            <a:pPr>
+              <a:defRPr sz="1600" b="1">
+                <a:solidFill>
+                  <a:srgbClr val="5856D6"/>
+                </a:solidFill>
+              </a:defRPr>
+            </a:pPr>
+            <a:r>
+              <a:t>🔐 JWT Authentication</a:t>
+            </a:r>
+          </a:p>
+        </p:txBody>
+      </p:sp>
+      <p:sp>
+        <p:nvSpPr>
+          <p:cNvPr id="6" name="TextBox 5"/>
+          <p:cNvSpPr txBox="1"/>
+          <p:nvPr/>
+        </p:nvSpPr>
+        <p:spPr>
+          <a:xfrm>
+            <a:off x="1828800" y="2057400"/>
+            <a:ext cx="5486400" cy="274320"/>
+          </a:xfrm>
+          <a:prstGeom prst="rect">
+            <a:avLst/>
+          </a:prstGeom>
+          <a:noFill/>
+        </p:spPr>
+        <p:txBody>
+          <a:bodyPr wrap="square">
+            <a:spAutoFit/>
+          </a:bodyPr>
+          <a:lstStyle/>
+          <a:p>
+            <a:pPr>
+              <a:defRPr sz="1200">
+                <a:solidFill>
+                  <a:srgbClr val="2D3748"/>
+                </a:solidFill>
+              </a:defRPr>
+            </a:pPr>
+            <a:r>
+              <a:t>Secure token-based authentication with expiration</a:t>
+            </a:r>
+          </a:p>
+        </p:txBody>
+      </p:sp>
+      <p:sp>
+        <p:nvSpPr>
+          <p:cNvPr id="7" name="Rounded Rectangle 6"/>
+          <p:cNvSpPr/>
+          <p:nvPr/>
+        </p:nvSpPr>
+        <p:spPr>
+          <a:xfrm>
+            <a:off x="1371600" y="2560320"/>
+            <a:ext cx="6400800" cy="777240"/>
+          </a:xfrm>
+          <a:prstGeom prst="roundRect">
+            <a:avLst/>
+          </a:prstGeom>
+          <a:solidFill>
+            <a:srgbClr val="FFFFFF"/>
+          </a:solidFill>
+          <a:ln w="38100">
+            <a:solidFill>
+              <a:srgbClr val="FF4785"/>
+            </a:solidFill>
+          </a:ln>
+        </p:spPr>
+        <p:style>
+          <a:lnRef idx="1">
+            <a:schemeClr val="accent1"/>
+          </a:lnRef>
+          <a:fillRef idx="3">
+            <a:schemeClr val="accent1"/>
+          </a:fillRef>
+          <a:effectRef idx="2">
+            <a:schemeClr val="accent1"/>
+          </a:effectRef>
+          <a:fontRef idx="minor">
+            <a:schemeClr val="lt1"/>
+          </a:fontRef>
+        </p:style>
+        <p:txBody>
+          <a:bodyPr rtlCol="0" anchor="ctr"/>
+          <a:lstStyle/>
+          <a:p>
+            <a:pPr algn="ctr"/>
+          </a:p>
+        </p:txBody>
+      </p:sp>
+      <p:sp>
+        <p:nvSpPr>
+          <p:cNvPr id="8" name="TextBox 7"/>
+          <p:cNvSpPr txBox="1"/>
+          <p:nvPr/>
+        </p:nvSpPr>
+        <p:spPr>
+          <a:xfrm>
+            <a:off x="1828800" y="2697479"/>
+            <a:ext cx="2743200" cy="274320"/>
+          </a:xfrm>
+          <a:prstGeom prst="rect">
+            <a:avLst/>
+          </a:prstGeom>
+          <a:noFill/>
+        </p:spPr>
+        <p:txBody>
+          <a:bodyPr wrap="none">
+            <a:spAutoFit/>
+          </a:bodyPr>
+          <a:lstStyle/>
+          <a:p>
+            <a:pPr>
+              <a:defRPr sz="1600" b="1">
+                <a:solidFill>
+                  <a:srgbClr val="FF4785"/>
+                </a:solidFill>
+              </a:defRPr>
+            </a:pPr>
+            <a:r>
+              <a:t>🛡️ RBAC Middleware</a:t>
+            </a:r>
+          </a:p>
+        </p:txBody>
+      </p:sp>
+      <p:sp>
+        <p:nvSpPr>
+          <p:cNvPr id="9" name="TextBox 8"/>
+          <p:cNvSpPr txBox="1"/>
+          <p:nvPr/>
+        </p:nvSpPr>
+        <p:spPr>
+          <a:xfrm>
+            <a:off x="1828800" y="2971800"/>
+            <a:ext cx="5486400" cy="274320"/>
+          </a:xfrm>
+          <a:prstGeom prst="rect">
+            <a:avLst/>
+          </a:prstGeom>
+          <a:noFill/>
+        </p:spPr>
+        <p:txBody>
+          <a:bodyPr wrap="square">
+            <a:spAutoFit/>
+          </a:bodyPr>
+          <a:lstStyle/>
+          <a:p>
+            <a:pPr>
+              <a:defRPr sz="1200">
+                <a:solidFill>
+                  <a:srgbClr val="2D3748"/>
+                </a:solidFill>
+              </a:defRPr>
+            </a:pPr>
+            <a:r>
+              <a:t>Role-based access control at API and data layer</a:t>
+            </a:r>
+          </a:p>
+        </p:txBody>
+      </p:sp>
+      <p:sp>
+        <p:nvSpPr>
+          <p:cNvPr id="10" name="Rounded Rectangle 9"/>
+          <p:cNvSpPr/>
+          <p:nvPr/>
+        </p:nvSpPr>
+        <p:spPr>
+          <a:xfrm>
+            <a:off x="1371600" y="3474720"/>
+            <a:ext cx="6400800" cy="777240"/>
+          </a:xfrm>
+          <a:prstGeom prst="roundRect">
+            <a:avLst/>
+          </a:prstGeom>
+          <a:solidFill>
+            <a:srgbClr val="FFFFFF"/>
+          </a:solidFill>
+          <a:ln w="38100">
+            <a:solidFill>
+              <a:srgbClr val="8A2BE2"/>
+            </a:solidFill>
+          </a:ln>
+        </p:spPr>
+        <p:style>
+          <a:lnRef idx="1">
+            <a:schemeClr val="accent1"/>
+          </a:lnRef>
+          <a:fillRef idx="3">
+            <a:schemeClr val="accent1"/>
+          </a:fillRef>
+          <a:effectRef idx="2">
+            <a:schemeClr val="accent1"/>
+          </a:effectRef>
+          <a:fontRef idx="minor">
+            <a:schemeClr val="lt1"/>
+          </a:fontRef>
+        </p:style>
+        <p:txBody>
+          <a:bodyPr rtlCol="0" anchor="ctr"/>
+          <a:lstStyle/>
+          <a:p>
+            <a:pPr algn="ctr"/>
+          </a:p>
+        </p:txBody>
+      </p:sp>
+      <p:sp>
+        <p:nvSpPr>
+          <p:cNvPr id="11" name="TextBox 10"/>
+          <p:cNvSpPr txBox="1"/>
+          <p:nvPr/>
+        </p:nvSpPr>
+        <p:spPr>
+          <a:xfrm>
+            <a:off x="1828800" y="3611879"/>
+            <a:ext cx="2743200" cy="274320"/>
+          </a:xfrm>
+          <a:prstGeom prst="rect">
+            <a:avLst/>
+          </a:prstGeom>
+          <a:noFill/>
+        </p:spPr>
+        <p:txBody>
+          <a:bodyPr wrap="none">
+            <a:spAutoFit/>
+          </a:bodyPr>
+          <a:lstStyle/>
+          <a:p>
+            <a:pPr>
+              <a:defRPr sz="1600" b="1">
+                <a:solidFill>
+                  <a:srgbClr val="8A2BE2"/>
+                </a:solidFill>
+              </a:defRPr>
+            </a:pPr>
+            <a:r>
+              <a:t>📝 Audit Logging</a:t>
+            </a:r>
+          </a:p>
+        </p:txBody>
+      </p:sp>
+      <p:sp>
+        <p:nvSpPr>
+          <p:cNvPr id="12" name="TextBox 11"/>
+          <p:cNvSpPr txBox="1"/>
+          <p:nvPr/>
+        </p:nvSpPr>
+        <p:spPr>
+          <a:xfrm>
+            <a:off x="1828800" y="3886200"/>
+            <a:ext cx="5486400" cy="274320"/>
+          </a:xfrm>
+          <a:prstGeom prst="rect">
+            <a:avLst/>
+          </a:prstGeom>
+          <a:noFill/>
+        </p:spPr>
+        <p:txBody>
+          <a:bodyPr wrap="square">
+            <a:spAutoFit/>
+          </a:bodyPr>
+          <a:lstStyle/>
+          <a:p>
+            <a:pPr>
+              <a:defRPr sz="1200">
+                <a:solidFill>
+                  <a:srgbClr val="2D3748"/>
+                </a:solidFill>
+              </a:defRPr>
+            </a:pPr>
+            <a:r>
+              <a:t>Complete audit trail of all user queries and access</a:t>
+            </a:r>
+          </a:p>
+        </p:txBody>
+      </p:sp>
+      <p:sp>
+        <p:nvSpPr>
+          <p:cNvPr id="13" name="Rounded Rectangle 12"/>
+          <p:cNvSpPr/>
+          <p:nvPr/>
+        </p:nvSpPr>
+        <p:spPr>
+          <a:xfrm>
+            <a:off x="1371600" y="4389120"/>
+            <a:ext cx="6400800" cy="777240"/>
+          </a:xfrm>
+          <a:prstGeom prst="roundRect">
+            <a:avLst/>
+          </a:prstGeom>
+          <a:solidFill>
+            <a:srgbClr val="FFFFFF"/>
+          </a:solidFill>
+          <a:ln w="38100">
+            <a:solidFill>
+              <a:srgbClr val="2ED573"/>
+            </a:solidFill>
+          </a:ln>
+        </p:spPr>
+        <p:style>
+          <a:lnRef idx="1">
+            <a:schemeClr val="accent1"/>
+          </a:lnRef>
+          <a:fillRef idx="3">
+            <a:schemeClr val="accent1"/>
+          </a:fillRef>
+          <a:effectRef idx="2">
+            <a:schemeClr val="accent1"/>
+          </a:effectRef>
+          <a:fontRef idx="minor">
+            <a:schemeClr val="lt1"/>
+          </a:fontRef>
+        </p:style>
+        <p:txBody>
+          <a:bodyPr rtlCol="0" anchor="ctr"/>
+          <a:lstStyle/>
+          <a:p>
+            <a:pPr algn="ctr"/>
+          </a:p>
+        </p:txBody>
+      </p:sp>
+      <p:sp>
+        <p:nvSpPr>
+          <p:cNvPr id="14" name="TextBox 13"/>
+          <p:cNvSpPr txBox="1"/>
+          <p:nvPr/>
+        </p:nvSpPr>
+        <p:spPr>
+          <a:xfrm>
+            <a:off x="1828800" y="4526280"/>
+            <a:ext cx="2743200" cy="274320"/>
+          </a:xfrm>
+          <a:prstGeom prst="rect">
+            <a:avLst/>
+          </a:prstGeom>
+          <a:noFill/>
+        </p:spPr>
+        <p:txBody>
+          <a:bodyPr wrap="none">
+            <a:spAutoFit/>
+          </a:bodyPr>
+          <a:lstStyle/>
+          <a:p>
+            <a:pPr>
+              <a:defRPr sz="1600" b="1">
+                <a:solidFill>
+                  <a:srgbClr val="2ED573"/>
+                </a:solidFill>
+              </a:defRPr>
+            </a:pPr>
+            <a:r>
+              <a:t>🔒 Password Hashing</a:t>
+            </a:r>
+          </a:p>
+        </p:txBody>
+      </p:sp>
+      <p:sp>
+        <p:nvSpPr>
+          <p:cNvPr id="15" name="TextBox 14"/>
+          <p:cNvSpPr txBox="1"/>
+          <p:nvPr/>
+        </p:nvSpPr>
+        <p:spPr>
+          <a:xfrm>
+            <a:off x="1828800" y="4800600"/>
+            <a:ext cx="5486400" cy="274320"/>
+          </a:xfrm>
+          <a:prstGeom prst="rect">
+            <a:avLst/>
+          </a:prstGeom>
+          <a:noFill/>
+        </p:spPr>
+        <p:txBody>
+          <a:bodyPr wrap="square">
+            <a:spAutoFit/>
+          </a:bodyPr>
+          <a:lstStyle/>
+          <a:p>
+            <a:pPr>
+              <a:defRPr sz="1200">
+                <a:solidFill>
+                  <a:srgbClr val="2D3748"/>
+                </a:solidFill>
+              </a:defRPr>
+            </a:pPr>
+            <a:r>
+              <a:t>Bcrypt hashing for secure password storage</a:t>
+            </a:r>
+          </a:p>
+        </p:txBody>
+      </p:sp>
+      <p:sp>
+        <p:nvSpPr>
+          <p:cNvPr id="16" name="Rounded Rectangle 15"/>
+          <p:cNvSpPr/>
+          <p:nvPr/>
+        </p:nvSpPr>
+        <p:spPr>
+          <a:xfrm>
+            <a:off x="1371600" y="5303520"/>
+            <a:ext cx="6400800" cy="777240"/>
+          </a:xfrm>
+          <a:prstGeom prst="roundRect">
+            <a:avLst/>
+          </a:prstGeom>
+          <a:solidFill>
+            <a:srgbClr val="FFFFFF"/>
+          </a:solidFill>
+          <a:ln w="38100">
+            <a:solidFill>
+              <a:srgbClr val="FF8C00"/>
+            </a:solidFill>
+          </a:ln>
+        </p:spPr>
+        <p:style>
+          <a:lnRef idx="1">
+            <a:schemeClr val="accent1"/>
+          </a:lnRef>
+          <a:fillRef idx="3">
+            <a:schemeClr val="accent1"/>
+          </a:fillRef>
+          <a:effectRef idx="2">
+            <a:schemeClr val="accent1"/>
+          </a:effectRef>
+          <a:fontRef idx="minor">
+            <a:schemeClr val="lt1"/>
+          </a:fontRef>
+        </p:style>
+        <p:txBody>
+          <a:bodyPr rtlCol="0" anchor="ctr"/>
+          <a:lstStyle/>
+          <a:p>
+            <a:pPr algn="ctr"/>
+          </a:p>
+        </p:txBody>
+      </p:sp>
+      <p:sp>
+        <p:nvSpPr>
+          <p:cNvPr id="17" name="TextBox 16"/>
+          <p:cNvSpPr txBox="1"/>
+          <p:nvPr/>
+        </p:nvSpPr>
+        <p:spPr>
+          <a:xfrm>
+            <a:off x="1828800" y="5440680"/>
+            <a:ext cx="2743200" cy="274320"/>
+          </a:xfrm>
+          <a:prstGeom prst="rect">
+            <a:avLst/>
+          </a:prstGeom>
+          <a:noFill/>
+        </p:spPr>
+        <p:txBody>
+          <a:bodyPr wrap="none">
+            <a:spAutoFit/>
+          </a:bodyPr>
+          <a:lstStyle/>
+          <a:p>
+            <a:pPr>
+              <a:defRPr sz="1600" b="1">
+                <a:solidFill>
+                  <a:srgbClr val="FF8C00"/>
+                </a:solidFill>
+              </a:defRPr>
+            </a:pPr>
+            <a:r>
+              <a:t>🚫 Department Filtering</a:t>
+            </a:r>
+          </a:p>
+        </p:txBody>
+      </p:sp>
+      <p:sp>
+        <p:nvSpPr>
+          <p:cNvPr id="18" name="TextBox 17"/>
+          <p:cNvSpPr txBox="1"/>
+          <p:nvPr/>
+        </p:nvSpPr>
+        <p:spPr>
+          <a:xfrm>
+            <a:off x="1828800" y="5715000"/>
+            <a:ext cx="5486400" cy="274320"/>
+          </a:xfrm>
+          <a:prstGeom prst="rect">
+            <a:avLst/>
+          </a:prstGeom>
+          <a:noFill/>
+        </p:spPr>
+        <p:txBody>
+          <a:bodyPr wrap="square">
+            <a:spAutoFit/>
+          </a:bodyPr>
+          <a:lstStyle/>
+          <a:p>
+            <a:pPr>
+              <a:defRPr sz="1200">
+                <a:solidFill>
+                  <a:srgbClr val="2D3748"/>
+                </a:solidFill>
+              </a:defRPr>
+            </a:pPr>
+            <a:r>
+              <a:t>Automatic filtering based on user department</a:t>
+            </a:r>
+          </a:p>
+        </p:txBody>
+      </p:sp>
+    </p:spTree>
+  </p:cSld>
+  <p:clrMapOvr>
+    <a:masterClrMapping/>
+  </p:clrMapOvr>
+</p:sld>
+</file>
+
+<file path=ppt/slides/slide11.xml><?xml version="1.0" encoding="utf-8"?>
+<p:sld xmlns:a="http://schemas.openxmlformats.org/drawingml/2006/main" xmlns:p="http://schemas.openxmlformats.org/presentationml/2006/main" xmlns:r="http://schemas.openxmlformats.org/officeDocument/2006/relationships">
+  <p:cSld>
+    <p:spTree>
+      <p:nvGrpSpPr>
+        <p:cNvPr id="1" name=""/>
+        <p:cNvGrpSpPr/>
+        <p:nvPr/>
+      </p:nvGrpSpPr>
+      <p:grpSpPr/>
+      <p:sp>
+        <p:nvSpPr>
+          <p:cNvPr id="2" name="Rectangle 1"/>
+          <p:cNvSpPr/>
+          <p:nvPr/>
+        </p:nvSpPr>
+        <p:spPr>
+          <a:xfrm>
+            <a:off x="0" y="0"/>
+            <a:ext cx="9144000" cy="6858000"/>
+          </a:xfrm>
+          <a:prstGeom prst="rect">
+            <a:avLst/>
+          </a:prstGeom>
+          <a:solidFill>
+            <a:srgbClr val="FFFFFF"/>
+          </a:solidFill>
+          <a:ln>
+            <a:noFill/>
+          </a:ln>
+        </p:spPr>
+        <p:style>
+          <a:lnRef idx="1">
+            <a:schemeClr val="accent1"/>
+          </a:lnRef>
+          <a:fillRef idx="3">
+            <a:schemeClr val="accent1"/>
+          </a:fillRef>
+          <a:effectRef idx="2">
+            <a:schemeClr val="accent1"/>
+          </a:effectRef>
+          <a:fontRef idx="minor">
+            <a:schemeClr val="lt1"/>
+          </a:fontRef>
+        </p:style>
+        <p:txBody>
+          <a:bodyPr rtlCol="0" anchor="ctr"/>
+          <a:lstStyle/>
+          <a:p>
+            <a:pPr algn="ctr"/>
+          </a:p>
+        </p:txBody>
+      </p:sp>
+      <p:sp>
+        <p:nvSpPr>
+          <p:cNvPr id="3" name="TextBox 2"/>
+          <p:cNvSpPr txBox="1"/>
+          <p:nvPr/>
+        </p:nvSpPr>
+        <p:spPr>
+          <a:xfrm>
+            <a:off x="914400" y="457200"/>
+            <a:ext cx="7315200" cy="731520"/>
+          </a:xfrm>
+          <a:prstGeom prst="rect">
+            <a:avLst/>
+          </a:prstGeom>
+          <a:noFill/>
+        </p:spPr>
+        <p:txBody>
+          <a:bodyPr wrap="none">
+            <a:spAutoFit/>
+          </a:bodyPr>
+          <a:lstStyle/>
+          <a:p>
+            <a:pPr algn="ctr">
+              <a:defRPr sz="3600" b="1">
+                <a:solidFill>
+                  <a:srgbClr val="5856D6"/>
+                </a:solidFill>
+              </a:defRPr>
+            </a:pPr>
+            <a:r>
+              <a:t>USE CASES</a:t>
+            </a:r>
+          </a:p>
+        </p:txBody>
+      </p:sp>
+      <p:sp>
+        <p:nvSpPr>
+          <p:cNvPr id="4" name="Rounded Rectangle 3"/>
+          <p:cNvSpPr/>
+          <p:nvPr/>
+        </p:nvSpPr>
+        <p:spPr>
+          <a:xfrm>
+            <a:off x="914400" y="1645920"/>
+            <a:ext cx="3200400" cy="1828800"/>
+          </a:xfrm>
+          <a:prstGeom prst="roundRect">
+            <a:avLst/>
+          </a:prstGeom>
+          <a:solidFill>
+            <a:srgbClr val="2ED573"/>
+          </a:solidFill>
+          <a:ln>
+            <a:noFill/>
+          </a:ln>
+        </p:spPr>
+        <p:style>
+          <a:lnRef idx="1">
+            <a:schemeClr val="accent1"/>
+          </a:lnRef>
+          <a:fillRef idx="3">
+            <a:schemeClr val="accent1"/>
+          </a:fillRef>
+          <a:effectRef idx="2">
+            <a:schemeClr val="accent1"/>
+          </a:effectRef>
+          <a:fontRef idx="minor">
+            <a:schemeClr val="lt1"/>
+          </a:fontRef>
+        </p:style>
+        <p:txBody>
+          <a:bodyPr rtlCol="0" anchor="ctr"/>
+          <a:lstStyle/>
+          <a:p>
+            <a:pPr algn="ctr"/>
+          </a:p>
+        </p:txBody>
+      </p:sp>
+      <p:sp>
+        <p:nvSpPr>
+          <p:cNvPr id="5" name="TextBox 4"/>
+          <p:cNvSpPr txBox="1"/>
+          <p:nvPr/>
+        </p:nvSpPr>
+        <p:spPr>
+          <a:xfrm>
+            <a:off x="1188720" y="1920240"/>
+            <a:ext cx="2651760" cy="457200"/>
+          </a:xfrm>
+          <a:prstGeom prst="rect">
+            <a:avLst/>
+          </a:prstGeom>
+          <a:noFill/>
+        </p:spPr>
+        <p:txBody>
+          <a:bodyPr wrap="none">
+            <a:spAutoFit/>
+          </a:bodyPr>
+          <a:lstStyle/>
+          <a:p>
+            <a:pPr algn="ctr">
+              <a:defRPr sz="2000" b="1">
+                <a:solidFill>
+                  <a:srgbClr val="FFFFFF"/>
+                </a:solidFill>
+              </a:defRPr>
+            </a:pPr>
+            <a:r>
+              <a:t>Finance Queries</a:t>
+            </a:r>
+          </a:p>
+        </p:txBody>
+      </p:sp>
+      <p:sp>
+        <p:nvSpPr>
+          <p:cNvPr id="6" name="TextBox 5"/>
+          <p:cNvSpPr txBox="1"/>
+          <p:nvPr/>
+        </p:nvSpPr>
+        <p:spPr>
+          <a:xfrm>
+            <a:off x="1188720" y="2468880"/>
+            <a:ext cx="2651760" cy="822960"/>
+          </a:xfrm>
+          <a:prstGeom prst="rect">
+            <a:avLst/>
+          </a:prstGeom>
+          <a:noFill/>
+        </p:spPr>
+        <p:txBody>
+          <a:bodyPr wrap="square">
+            <a:spAutoFit/>
+          </a:bodyPr>
+          <a:lstStyle/>
+          <a:p>
+            <a:pPr algn="ctr">
+              <a:defRPr sz="1300">
+                <a:solidFill>
+                  <a:srgbClr val="FFFFFF"/>
+                </a:solidFill>
+              </a:defRPr>
+            </a:pPr>
+            <a:r>
+              <a:t>Access financial reports</a:t>
+            </a:r>
+            <a:br/>
+            <a:r>
+              <a:t>Quarterly statements</a:t>
+            </a:r>
+            <a:br/>
+            <a:r>
+              <a:t>Budget information</a:t>
+            </a:r>
+          </a:p>
+        </p:txBody>
+      </p:sp>
+      <p:sp>
+        <p:nvSpPr>
+          <p:cNvPr id="7" name="Rounded Rectangle 6"/>
+          <p:cNvSpPr/>
+          <p:nvPr/>
+        </p:nvSpPr>
+        <p:spPr>
+          <a:xfrm>
+            <a:off x="5029200" y="1645920"/>
+            <a:ext cx="3200400" cy="1828800"/>
+          </a:xfrm>
+          <a:prstGeom prst="roundRect">
+            <a:avLst/>
+          </a:prstGeom>
+          <a:solidFill>
+            <a:srgbClr val="FF4785"/>
+          </a:solidFill>
+          <a:ln>
+            <a:noFill/>
+          </a:ln>
+        </p:spPr>
+        <p:style>
+          <a:lnRef idx="1">
+            <a:schemeClr val="accent1"/>
+          </a:lnRef>
+          <a:fillRef idx="3">
+            <a:schemeClr val="accent1"/>
+          </a:fillRef>
+          <a:effectRef idx="2">
+            <a:schemeClr val="accent1"/>
+          </a:effectRef>
+          <a:fontRef idx="minor">
+            <a:schemeClr val="lt1"/>
+          </a:fontRef>
+        </p:style>
+        <p:txBody>
+          <a:bodyPr rtlCol="0" anchor="ctr"/>
+          <a:lstStyle/>
+          <a:p>
+            <a:pPr algn="ctr"/>
+          </a:p>
+        </p:txBody>
+      </p:sp>
+      <p:sp>
+        <p:nvSpPr>
+          <p:cNvPr id="8" name="TextBox 7"/>
+          <p:cNvSpPr txBox="1"/>
+          <p:nvPr/>
+        </p:nvSpPr>
+        <p:spPr>
+          <a:xfrm>
+            <a:off x="5303520" y="1920240"/>
+            <a:ext cx="2651760" cy="457200"/>
+          </a:xfrm>
+          <a:prstGeom prst="rect">
+            <a:avLst/>
+          </a:prstGeom>
+          <a:noFill/>
+        </p:spPr>
+        <p:txBody>
+          <a:bodyPr wrap="none">
+            <a:spAutoFit/>
+          </a:bodyPr>
+          <a:lstStyle/>
+          <a:p>
+            <a:pPr algn="ctr">
+              <a:defRPr sz="2000" b="1">
+                <a:solidFill>
+                  <a:srgbClr val="FFFFFF"/>
+                </a:solidFill>
+              </a:defRPr>
+            </a:pPr>
+            <a:r>
+              <a:t>HR Information</a:t>
+            </a:r>
+          </a:p>
+        </p:txBody>
+      </p:sp>
+      <p:sp>
+        <p:nvSpPr>
+          <p:cNvPr id="9" name="TextBox 8"/>
+          <p:cNvSpPr txBox="1"/>
+          <p:nvPr/>
+        </p:nvSpPr>
+        <p:spPr>
+          <a:xfrm>
+            <a:off x="5303520" y="2468880"/>
+            <a:ext cx="2651760" cy="822960"/>
+          </a:xfrm>
+          <a:prstGeom prst="rect">
+            <a:avLst/>
+          </a:prstGeom>
+          <a:noFill/>
+        </p:spPr>
+        <p:txBody>
+          <a:bodyPr wrap="square">
+            <a:spAutoFit/>
+          </a:bodyPr>
+          <a:lstStyle/>
+          <a:p>
+            <a:pPr algn="ctr">
+              <a:defRPr sz="1300">
+                <a:solidFill>
+                  <a:srgbClr val="FFFFFF"/>
+                </a:solidFill>
+              </a:defRPr>
+            </a:pPr>
+            <a:r>
+              <a:t>Employee policies</a:t>
+            </a:r>
+            <a:br/>
+            <a:r>
+              <a:t>Payroll queries</a:t>
+            </a:r>
+            <a:br/>
+            <a:r>
+              <a:t>Benefits information</a:t>
+            </a:r>
+          </a:p>
+        </p:txBody>
+      </p:sp>
+      <p:sp>
+        <p:nvSpPr>
+          <p:cNvPr id="10" name="Rounded Rectangle 9"/>
+          <p:cNvSpPr/>
+          <p:nvPr/>
+        </p:nvSpPr>
+        <p:spPr>
+          <a:xfrm>
+            <a:off x="914400" y="3931920"/>
+            <a:ext cx="3200400" cy="1828800"/>
+          </a:xfrm>
+          <a:prstGeom prst="roundRect">
+            <a:avLst/>
+          </a:prstGeom>
+          <a:solidFill>
+            <a:srgbClr val="FF8C00"/>
+          </a:solidFill>
+          <a:ln>
+            <a:noFill/>
+          </a:ln>
+        </p:spPr>
+        <p:style>
+          <a:lnRef idx="1">
+            <a:schemeClr val="accent1"/>
+          </a:lnRef>
+          <a:fillRef idx="3">
+            <a:schemeClr val="accent1"/>
+          </a:fillRef>
+          <a:effectRef idx="2">
+            <a:schemeClr val="accent1"/>
+          </a:effectRef>
+          <a:fontRef idx="minor">
+            <a:schemeClr val="lt1"/>
+          </a:fontRef>
+        </p:style>
+        <p:txBody>
+          <a:bodyPr rtlCol="0" anchor="ctr"/>
+          <a:lstStyle/>
+          <a:p>
+            <a:pPr algn="ctr"/>
+          </a:p>
+        </p:txBody>
+      </p:sp>
+      <p:sp>
+        <p:nvSpPr>
+          <p:cNvPr id="11" name="TextBox 10"/>
+          <p:cNvSpPr txBox="1"/>
+          <p:nvPr/>
+        </p:nvSpPr>
+        <p:spPr>
+          <a:xfrm>
+            <a:off x="1188720" y="4206240"/>
+            <a:ext cx="2651760" cy="457200"/>
+          </a:xfrm>
+          <a:prstGeom prst="rect">
+            <a:avLst/>
+          </a:prstGeom>
+          <a:noFill/>
+        </p:spPr>
+        <p:txBody>
+          <a:bodyPr wrap="none">
+            <a:spAutoFit/>
+          </a:bodyPr>
+          <a:lstStyle/>
+          <a:p>
+            <a:pPr algn="ctr">
+              <a:defRPr sz="2000" b="1">
+                <a:solidFill>
+                  <a:srgbClr val="FFFFFF"/>
+                </a:solidFill>
+              </a:defRPr>
+            </a:pPr>
+            <a:r>
+              <a:t>Marketing Data</a:t>
+            </a:r>
+          </a:p>
+        </p:txBody>
+      </p:sp>
+      <p:sp>
+        <p:nvSpPr>
+          <p:cNvPr id="12" name="TextBox 11"/>
+          <p:cNvSpPr txBox="1"/>
+          <p:nvPr/>
+        </p:nvSpPr>
+        <p:spPr>
+          <a:xfrm>
+            <a:off x="1188720" y="4754880"/>
+            <a:ext cx="2651760" cy="822960"/>
+          </a:xfrm>
+          <a:prstGeom prst="rect">
+            <a:avLst/>
+          </a:prstGeom>
+          <a:noFill/>
+        </p:spPr>
+        <p:txBody>
+          <a:bodyPr wrap="square">
+            <a:spAutoFit/>
+          </a:bodyPr>
+          <a:lstStyle/>
+          <a:p>
+            <a:pPr algn="ctr">
+              <a:defRPr sz="1300">
+                <a:solidFill>
+                  <a:srgbClr val="FFFFFF"/>
+                </a:solidFill>
+              </a:defRPr>
+            </a:pPr>
+            <a:r>
+              <a:t>Campaign analytics</a:t>
+            </a:r>
+            <a:br/>
+            <a:r>
+              <a:t>Market research</a:t>
+            </a:r>
+            <a:br/>
+            <a:r>
+              <a:t>Performance reports</a:t>
+            </a:r>
+          </a:p>
+        </p:txBody>
+      </p:sp>
+      <p:sp>
+        <p:nvSpPr>
+          <p:cNvPr id="13" name="Rounded Rectangle 12"/>
+          <p:cNvSpPr/>
+          <p:nvPr/>
+        </p:nvSpPr>
+        <p:spPr>
+          <a:xfrm>
+            <a:off x="5029200" y="3931920"/>
+            <a:ext cx="3200400" cy="1828800"/>
+          </a:xfrm>
+          <a:prstGeom prst="roundRect">
+            <a:avLst/>
+          </a:prstGeom>
+          <a:solidFill>
+            <a:srgbClr val="5856D6"/>
+          </a:solidFill>
+          <a:ln>
+            <a:noFill/>
+          </a:ln>
+        </p:spPr>
+        <p:style>
+          <a:lnRef idx="1">
+            <a:schemeClr val="accent1"/>
+          </a:lnRef>
+          <a:fillRef idx="3">
+            <a:schemeClr val="accent1"/>
+          </a:fillRef>
+          <a:effectRef idx="2">
+            <a:schemeClr val="accent1"/>
+          </a:effectRef>
+          <a:fontRef idx="minor">
+            <a:schemeClr val="lt1"/>
+          </a:fontRef>
+        </p:style>
+        <p:txBody>
+          <a:bodyPr rtlCol="0" anchor="ctr"/>
+          <a:lstStyle/>
+          <a:p>
+            <a:pPr algn="ctr"/>
+          </a:p>
+        </p:txBody>
+      </p:sp>
+      <p:sp>
+        <p:nvSpPr>
+          <p:cNvPr id="14" name="TextBox 13"/>
+          <p:cNvSpPr txBox="1"/>
+          <p:nvPr/>
+        </p:nvSpPr>
+        <p:spPr>
+          <a:xfrm>
+            <a:off x="5303520" y="4206240"/>
+            <a:ext cx="2651760" cy="457200"/>
+          </a:xfrm>
+          <a:prstGeom prst="rect">
+            <a:avLst/>
+          </a:prstGeom>
+          <a:noFill/>
+        </p:spPr>
+        <p:txBody>
+          <a:bodyPr wrap="none">
+            <a:spAutoFit/>
+          </a:bodyPr>
+          <a:lstStyle/>
+          <a:p>
+            <a:pPr algn="ctr">
+              <a:defRPr sz="2000" b="1">
+                <a:solidFill>
+                  <a:srgbClr val="FFFFFF"/>
+                </a:solidFill>
+              </a:defRPr>
+            </a:pPr>
+            <a:r>
+              <a:t>Technical Docs</a:t>
+            </a:r>
+          </a:p>
+        </p:txBody>
+      </p:sp>
+      <p:sp>
+        <p:nvSpPr>
+          <p:cNvPr id="15" name="TextBox 14"/>
+          <p:cNvSpPr txBox="1"/>
+          <p:nvPr/>
+        </p:nvSpPr>
+        <p:spPr>
+          <a:xfrm>
+            <a:off x="5303520" y="4754880"/>
+            <a:ext cx="2651760" cy="822960"/>
+          </a:xfrm>
+          <a:prstGeom prst="rect">
+            <a:avLst/>
+          </a:prstGeom>
+          <a:noFill/>
+        </p:spPr>
+        <p:txBody>
+          <a:bodyPr wrap="square">
+            <a:spAutoFit/>
+          </a:bodyPr>
+          <a:lstStyle/>
+          <a:p>
+            <a:pPr algn="ctr">
+              <a:defRPr sz="1300">
+                <a:solidFill>
+                  <a:srgbClr val="FFFFFF"/>
+                </a:solidFill>
+              </a:defRPr>
+            </a:pPr>
+            <a:r>
+              <a:t>API documentation</a:t>
+            </a:r>
+            <a:br/>
+            <a:r>
+              <a:t>Architecture guides</a:t>
+            </a:r>
+            <a:br/>
+            <a:r>
+              <a:t>Engineering specs</a:t>
+            </a:r>
+          </a:p>
+        </p:txBody>
+      </p:sp>
+    </p:spTree>
+  </p:cSld>
+  <p:clrMapOvr>
+    <a:masterClrMapping/>
+  </p:clrMapOvr>
+</p:sld>
+</file>
+
+<file path=ppt/slides/slide12.xml><?xml version="1.0" encoding="utf-8"?>
+<p:sld xmlns:a="http://schemas.openxmlformats.org/drawingml/2006/main" xmlns:p="http://schemas.openxmlformats.org/presentationml/2006/main" xmlns:r="http://schemas.openxmlformats.org/officeDocument/2006/relationships">
+  <p:cSld>
+    <p:spTree>
+      <p:nvGrpSpPr>
+        <p:cNvPr id="1" name=""/>
+        <p:cNvGrpSpPr/>
+        <p:nvPr/>
+      </p:nvGrpSpPr>
+      <p:grpSpPr/>
+      <p:sp>
+        <p:nvSpPr>
+          <p:cNvPr id="2" name="Rectangle 1"/>
+          <p:cNvSpPr/>
+          <p:nvPr/>
+        </p:nvSpPr>
+        <p:spPr>
+          <a:xfrm>
+            <a:off x="0" y="0"/>
+            <a:ext cx="9144000" cy="6858000"/>
+          </a:xfrm>
+          <a:prstGeom prst="rect">
+            <a:avLst/>
+          </a:prstGeom>
+          <a:solidFill>
+            <a:srgbClr val="F8FAFC"/>
+          </a:solidFill>
+          <a:ln>
+            <a:noFill/>
+          </a:ln>
+        </p:spPr>
+        <p:style>
+          <a:lnRef idx="1">
+            <a:schemeClr val="accent1"/>
+          </a:lnRef>
+          <a:fillRef idx="3">
+            <a:schemeClr val="accent1"/>
+          </a:fillRef>
+          <a:effectRef idx="2">
+            <a:schemeClr val="accent1"/>
+          </a:effectRef>
+          <a:fontRef idx="minor">
+            <a:schemeClr val="lt1"/>
+          </a:fontRef>
+        </p:style>
+        <p:txBody>
+          <a:bodyPr rtlCol="0" anchor="ctr"/>
+          <a:lstStyle/>
+          <a:p>
+            <a:pPr algn="ctr"/>
+          </a:p>
+        </p:txBody>
+      </p:sp>
+      <p:sp>
+        <p:nvSpPr>
+          <p:cNvPr id="3" name="TextBox 2"/>
+          <p:cNvSpPr txBox="1"/>
+          <p:nvPr/>
+        </p:nvSpPr>
+        <p:spPr>
+          <a:xfrm>
+            <a:off x="914400" y="457200"/>
+            <a:ext cx="7315200" cy="731520"/>
+          </a:xfrm>
+          <a:prstGeom prst="rect">
+            <a:avLst/>
+          </a:prstGeom>
+          <a:noFill/>
+        </p:spPr>
+        <p:txBody>
+          <a:bodyPr wrap="none">
+            <a:spAutoFit/>
+          </a:bodyPr>
+          <a:lstStyle/>
+          <a:p>
+            <a:pPr algn="ctr">
+              <a:defRPr sz="3600" b="1">
+                <a:solidFill>
+                  <a:srgbClr val="8A2BE2"/>
+                </a:solidFill>
+              </a:defRPr>
+            </a:pPr>
+            <a:r>
+              <a:t>DEPLOYMENT ARCHITECTURE</a:t>
+            </a:r>
+          </a:p>
+        </p:txBody>
+      </p:sp>
+      <p:sp>
+        <p:nvSpPr>
+          <p:cNvPr id="4" name="Rounded Rectangle 3"/>
+          <p:cNvSpPr/>
+          <p:nvPr/>
+        </p:nvSpPr>
+        <p:spPr>
+          <a:xfrm>
+            <a:off x="1828800" y="1828800"/>
+            <a:ext cx="2286000" cy="1371600"/>
+          </a:xfrm>
+          <a:prstGeom prst="roundRect">
+            <a:avLst/>
+          </a:prstGeom>
+          <a:solidFill>
+            <a:srgbClr val="5856D6"/>
+          </a:solidFill>
+          <a:ln>
+            <a:noFill/>
+          </a:ln>
+        </p:spPr>
+        <p:style>
+          <a:lnRef idx="1">
+            <a:schemeClr val="accent1"/>
+          </a:lnRef>
+          <a:fillRef idx="3">
+            <a:schemeClr val="accent1"/>
+          </a:fillRef>
+          <a:effectRef idx="2">
+            <a:schemeClr val="accent1"/>
+          </a:effectRef>
+          <a:fontRef idx="minor">
+            <a:schemeClr val="lt1"/>
+          </a:fontRef>
+        </p:style>
+        <p:txBody>
+          <a:bodyPr rtlCol="0" anchor="ctr"/>
+          <a:lstStyle/>
+          <a:p>
+            <a:pPr algn="ctr"/>
+          </a:p>
+        </p:txBody>
+      </p:sp>
+      <p:sp>
+        <p:nvSpPr>
+          <p:cNvPr id="5" name="TextBox 4"/>
+          <p:cNvSpPr txBox="1"/>
+          <p:nvPr/>
+        </p:nvSpPr>
+        <p:spPr>
+          <a:xfrm>
+            <a:off x="2011680" y="2103120"/>
+            <a:ext cx="1920240" cy="365760"/>
+          </a:xfrm>
+          <a:prstGeom prst="rect">
+            <a:avLst/>
+          </a:prstGeom>
+          <a:noFill/>
+        </p:spPr>
+        <p:txBody>
+          <a:bodyPr wrap="none">
+            <a:spAutoFit/>
+          </a:bodyPr>
+          <a:lstStyle/>
+          <a:p>
+            <a:pPr algn="ctr">
+              <a:defRPr sz="1800" b="1">
+                <a:solidFill>
+                  <a:srgbClr val="FFFFFF"/>
+                </a:solidFill>
+              </a:defRPr>
+            </a:pPr>
+            <a:r>
+              <a:t>FastAPI Backend</a:t>
+            </a:r>
+          </a:p>
+        </p:txBody>
+      </p:sp>
+      <p:sp>
+        <p:nvSpPr>
+          <p:cNvPr id="6" name="TextBox 5"/>
+          <p:cNvSpPr txBox="1"/>
+          <p:nvPr/>
+        </p:nvSpPr>
+        <p:spPr>
+          <a:xfrm>
+            <a:off x="2011680" y="2560320"/>
+            <a:ext cx="1920240" cy="457200"/>
+          </a:xfrm>
+          <a:prstGeom prst="rect">
+            <a:avLst/>
+          </a:prstGeom>
+          <a:noFill/>
+        </p:spPr>
+        <p:txBody>
+          <a:bodyPr wrap="square">
+            <a:spAutoFit/>
+          </a:bodyPr>
+          <a:lstStyle/>
+          <a:p>
+            <a:pPr algn="ctr">
+              <a:defRPr sz="1200">
+                <a:solidFill>
+                  <a:srgbClr val="FFFFFF"/>
+                </a:solidFill>
+              </a:defRPr>
+            </a:pPr>
+            <a:r>
+              <a:t>RESTful API server</a:t>
+            </a:r>
+            <a:br/>
+            <a:r>
+              <a:t>Port 8000</a:t>
+            </a:r>
+          </a:p>
+        </p:txBody>
+      </p:sp>
+      <p:sp>
+        <p:nvSpPr>
+          <p:cNvPr id="7" name="Rounded Rectangle 6"/>
+          <p:cNvSpPr/>
+          <p:nvPr/>
+        </p:nvSpPr>
+        <p:spPr>
+          <a:xfrm>
+            <a:off x="5029200" y="1828800"/>
+            <a:ext cx="2286000" cy="1371600"/>
+          </a:xfrm>
+          <a:prstGeom prst="roundRect">
+            <a:avLst/>
+          </a:prstGeom>
+          <a:solidFill>
+            <a:srgbClr val="FF4785"/>
+          </a:solidFill>
+          <a:ln>
+            <a:noFill/>
+          </a:ln>
+        </p:spPr>
+        <p:style>
+          <a:lnRef idx="1">
+            <a:schemeClr val="accent1"/>
+          </a:lnRef>
+          <a:fillRef idx="3">
+            <a:schemeClr val="accent1"/>
+          </a:fillRef>
+          <a:effectRef idx="2">
+            <a:schemeClr val="accent1"/>
+          </a:effectRef>
+          <a:fontRef idx="minor">
+            <a:schemeClr val="lt1"/>
+          </a:fontRef>
+        </p:style>
+        <p:txBody>
+          <a:bodyPr rtlCol="0" anchor="ctr"/>
+          <a:lstStyle/>
+          <a:p>
+            <a:pPr algn="ctr"/>
+          </a:p>
+        </p:txBody>
+      </p:sp>
+      <p:sp>
+        <p:nvSpPr>
+          <p:cNvPr id="8" name="TextBox 7"/>
+          <p:cNvSpPr txBox="1"/>
+          <p:nvPr/>
+        </p:nvSpPr>
+        <p:spPr>
+          <a:xfrm>
+            <a:off x="5212080" y="2103120"/>
+            <a:ext cx="1920240" cy="365760"/>
+          </a:xfrm>
+          <a:prstGeom prst="rect">
+            <a:avLst/>
+          </a:prstGeom>
+          <a:noFill/>
+        </p:spPr>
+        <p:txBody>
+          <a:bodyPr wrap="none">
+            <a:spAutoFit/>
+          </a:bodyPr>
+          <a:lstStyle/>
+          <a:p>
+            <a:pPr algn="ctr">
+              <a:defRPr sz="1800" b="1">
+                <a:solidFill>
+                  <a:srgbClr val="FFFFFF"/>
+                </a:solidFill>
+              </a:defRPr>
+            </a:pPr>
+            <a:r>
+              <a:t>Streamlit UI</a:t>
+            </a:r>
+          </a:p>
+        </p:txBody>
+      </p:sp>
+      <p:sp>
+        <p:nvSpPr>
+          <p:cNvPr id="9" name="TextBox 8"/>
+          <p:cNvSpPr txBox="1"/>
+          <p:nvPr/>
+        </p:nvSpPr>
+        <p:spPr>
+          <a:xfrm>
+            <a:off x="5212080" y="2560320"/>
+            <a:ext cx="1920240" cy="457200"/>
+          </a:xfrm>
+          <a:prstGeom prst="rect">
+            <a:avLst/>
+          </a:prstGeom>
+          <a:noFill/>
+        </p:spPr>
+        <p:txBody>
+          <a:bodyPr wrap="square">
+            <a:spAutoFit/>
+          </a:bodyPr>
+          <a:lstStyle/>
+          <a:p>
+            <a:pPr algn="ctr">
+              <a:defRPr sz="1200">
+                <a:solidFill>
+                  <a:srgbClr val="FFFFFF"/>
+                </a:solidFill>
+              </a:defRPr>
+            </a:pPr>
+            <a:r>
+              <a:t>Web interface</a:t>
+            </a:r>
+            <a:br/>
+            <a:r>
+              <a:t>Port 8501</a:t>
+            </a:r>
+          </a:p>
+        </p:txBody>
+      </p:sp>
+      <p:sp>
+        <p:nvSpPr>
+          <p:cNvPr id="10" name="Rounded Rectangle 9"/>
+          <p:cNvSpPr/>
+          <p:nvPr/>
+        </p:nvSpPr>
+        <p:spPr>
+          <a:xfrm>
+            <a:off x="1828800" y="3657600"/>
+            <a:ext cx="2286000" cy="1371600"/>
+          </a:xfrm>
+          <a:prstGeom prst="roundRect">
+            <a:avLst/>
+          </a:prstGeom>
+          <a:solidFill>
+            <a:srgbClr val="2ED573"/>
+          </a:solidFill>
+          <a:ln>
+            <a:noFill/>
+          </a:ln>
+        </p:spPr>
+        <p:style>
+          <a:lnRef idx="1">
+            <a:schemeClr val="accent1"/>
+          </a:lnRef>
+          <a:fillRef idx="3">
+            <a:schemeClr val="accent1"/>
+          </a:fillRef>
+          <a:effectRef idx="2">
+            <a:schemeClr val="accent1"/>
+          </a:effectRef>
+          <a:fontRef idx="minor">
+            <a:schemeClr val="lt1"/>
+          </a:fontRef>
+        </p:style>
+        <p:txBody>
+          <a:bodyPr rtlCol="0" anchor="ctr"/>
+          <a:lstStyle/>
+          <a:p>
+            <a:pPr algn="ctr"/>
+          </a:p>
+        </p:txBody>
+      </p:sp>
+      <p:sp>
+        <p:nvSpPr>
+          <p:cNvPr id="11" name="TextBox 10"/>
+          <p:cNvSpPr txBox="1"/>
+          <p:nvPr/>
+        </p:nvSpPr>
+        <p:spPr>
+          <a:xfrm>
+            <a:off x="2011680" y="3931920"/>
+            <a:ext cx="1920240" cy="365760"/>
+          </a:xfrm>
+          <a:prstGeom prst="rect">
+            <a:avLst/>
+          </a:prstGeom>
+          <a:noFill/>
+        </p:spPr>
+        <p:txBody>
+          <a:bodyPr wrap="none">
+            <a:spAutoFit/>
+          </a:bodyPr>
+          <a:lstStyle/>
+          <a:p>
+            <a:pPr algn="ctr">
+              <a:defRPr sz="1800" b="1">
+                <a:solidFill>
+                  <a:srgbClr val="FFFFFF"/>
+                </a:solidFill>
+              </a:defRPr>
+            </a:pPr>
+            <a:r>
+              <a:t>ChromaDB</a:t>
+            </a:r>
+          </a:p>
+        </p:txBody>
+      </p:sp>
+      <p:sp>
+        <p:nvSpPr>
+          <p:cNvPr id="12" name="TextBox 11"/>
+          <p:cNvSpPr txBox="1"/>
+          <p:nvPr/>
+        </p:nvSpPr>
+        <p:spPr>
+          <a:xfrm>
+            <a:off x="2011680" y="4389120"/>
+            <a:ext cx="1920240" cy="457200"/>
+          </a:xfrm>
+          <a:prstGeom prst="rect">
+            <a:avLst/>
+          </a:prstGeom>
+          <a:noFill/>
+        </p:spPr>
+        <p:txBody>
+          <a:bodyPr wrap="square">
+            <a:spAutoFit/>
+          </a:bodyPr>
+          <a:lstStyle/>
+          <a:p>
+            <a:pPr algn="ctr">
+              <a:defRPr sz="1200">
+                <a:solidFill>
+                  <a:srgbClr val="FFFFFF"/>
+                </a:solidFill>
+              </a:defRPr>
+            </a:pPr>
+            <a:r>
+              <a:t>Vector database</a:t>
+            </a:r>
+            <a:br/>
+            <a:r>
+              <a:t>Persistent storage</a:t>
+            </a:r>
+          </a:p>
+        </p:txBody>
+      </p:sp>
+      <p:sp>
+        <p:nvSpPr>
+          <p:cNvPr id="13" name="Rounded Rectangle 12"/>
+          <p:cNvSpPr/>
+          <p:nvPr/>
+        </p:nvSpPr>
+        <p:spPr>
+          <a:xfrm>
+            <a:off x="5029200" y="3657600"/>
+            <a:ext cx="2286000" cy="1371600"/>
+          </a:xfrm>
+          <a:prstGeom prst="roundRect">
+            <a:avLst/>
+          </a:prstGeom>
+          <a:solidFill>
+            <a:srgbClr val="FF8C00"/>
+          </a:solidFill>
+          <a:ln>
+            <a:noFill/>
+          </a:ln>
+        </p:spPr>
+        <p:style>
+          <a:lnRef idx="1">
+            <a:schemeClr val="accent1"/>
+          </a:lnRef>
+          <a:fillRef idx="3">
+            <a:schemeClr val="accent1"/>
+          </a:fillRef>
+          <a:effectRef idx="2">
+            <a:schemeClr val="accent1"/>
+          </a:effectRef>
+          <a:fontRef idx="minor">
+            <a:schemeClr val="lt1"/>
+          </a:fontRef>
+        </p:style>
+        <p:txBody>
+          <a:bodyPr rtlCol="0" anchor="ctr"/>
+          <a:lstStyle/>
+          <a:p>
+            <a:pPr algn="ctr"/>
+          </a:p>
+        </p:txBody>
+      </p:sp>
+      <p:sp>
+        <p:nvSpPr>
+          <p:cNvPr id="14" name="TextBox 13"/>
+          <p:cNvSpPr txBox="1"/>
+          <p:nvPr/>
+        </p:nvSpPr>
+        <p:spPr>
+          <a:xfrm>
+            <a:off x="5212080" y="3931920"/>
+            <a:ext cx="1920240" cy="365760"/>
+          </a:xfrm>
+          <a:prstGeom prst="rect">
+            <a:avLst/>
+          </a:prstGeom>
+          <a:noFill/>
+        </p:spPr>
+        <p:txBody>
+          <a:bodyPr wrap="none">
+            <a:spAutoFit/>
+          </a:bodyPr>
+          <a:lstStyle/>
+          <a:p>
+            <a:pPr algn="ctr">
+              <a:defRPr sz="1800" b="1">
+                <a:solidFill>
+                  <a:srgbClr val="FFFFFF"/>
+                </a:solidFill>
+              </a:defRPr>
+            </a:pPr>
+            <a:r>
+              <a:t>OpenRouter API</a:t>
+            </a:r>
+          </a:p>
+        </p:txBody>
+      </p:sp>
+      <p:sp>
+        <p:nvSpPr>
+          <p:cNvPr id="15" name="TextBox 14"/>
+          <p:cNvSpPr txBox="1"/>
+          <p:nvPr/>
+        </p:nvSpPr>
+        <p:spPr>
+          <a:xfrm>
+            <a:off x="5212080" y="4389120"/>
+            <a:ext cx="1920240" cy="457200"/>
+          </a:xfrm>
+          <a:prstGeom prst="rect">
+            <a:avLst/>
+          </a:prstGeom>
+          <a:noFill/>
+        </p:spPr>
+        <p:txBody>
+          <a:bodyPr wrap="square">
+            <a:spAutoFit/>
+          </a:bodyPr>
+          <a:lstStyle/>
+          <a:p>
+            <a:pPr algn="ctr">
+              <a:defRPr sz="1200">
+                <a:solidFill>
+                  <a:srgbClr val="FFFFFF"/>
+                </a:solidFill>
+              </a:defRPr>
+            </a:pPr>
+            <a:r>
+              <a:t>LLM provider</a:t>
+            </a:r>
+            <a:br/>
+            <a:r>
+              <a:t>Mistral 7B</a:t>
+            </a:r>
+          </a:p>
+        </p:txBody>
+      </p:sp>
+    </p:spTree>
+  </p:cSld>
+  <p:clrMapOvr>
+    <a:masterClrMapping/>
+  </p:clrMapOvr>
+</p:sld>
+</file>
+
+<file path=ppt/slides/slide13.xml><?xml version="1.0" encoding="utf-8"?>
+<p:sld xmlns:a="http://schemas.openxmlformats.org/drawingml/2006/main" xmlns:p="http://schemas.openxmlformats.org/presentationml/2006/main" xmlns:r="http://schemas.openxmlformats.org/officeDocument/2006/relationships">
+  <p:cSld>
+    <p:spTree>
+      <p:nvGrpSpPr>
+        <p:cNvPr id="1" name=""/>
+        <p:cNvGrpSpPr/>
+        <p:nvPr/>
+      </p:nvGrpSpPr>
+      <p:grpSpPr/>
+      <p:sp>
+        <p:nvSpPr>
+          <p:cNvPr id="2" name="Rectangle 1"/>
+          <p:cNvSpPr/>
+          <p:nvPr/>
+        </p:nvSpPr>
+        <p:spPr>
+          <a:xfrm>
+            <a:off x="0" y="0"/>
+            <a:ext cx="9144000" cy="6858000"/>
+          </a:xfrm>
+          <a:prstGeom prst="rect">
+            <a:avLst/>
+          </a:prstGeom>
+          <a:solidFill>
+            <a:srgbClr val="FFFFFF"/>
+          </a:solidFill>
+          <a:ln>
+            <a:noFill/>
+          </a:ln>
+        </p:spPr>
+        <p:style>
+          <a:lnRef idx="1">
+            <a:schemeClr val="accent1"/>
+          </a:lnRef>
+          <a:fillRef idx="3">
+            <a:schemeClr val="accent1"/>
+          </a:fillRef>
+          <a:effectRef idx="2">
+            <a:schemeClr val="accent1"/>
+          </a:effectRef>
+          <a:fontRef idx="minor">
+            <a:schemeClr val="lt1"/>
+          </a:fontRef>
+        </p:style>
+        <p:txBody>
+          <a:bodyPr rtlCol="0" anchor="ctr"/>
+          <a:lstStyle/>
+          <a:p>
+            <a:pPr algn="ctr"/>
+          </a:p>
+        </p:txBody>
+      </p:sp>
+      <p:sp>
+        <p:nvSpPr>
+          <p:cNvPr id="3" name="TextBox 2"/>
+          <p:cNvSpPr txBox="1"/>
+          <p:nvPr/>
+        </p:nvSpPr>
+        <p:spPr>
+          <a:xfrm>
+            <a:off x="914400" y="457200"/>
+            <a:ext cx="7315200" cy="731520"/>
+          </a:xfrm>
+          <a:prstGeom prst="rect">
+            <a:avLst/>
+          </a:prstGeom>
+          <a:noFill/>
+        </p:spPr>
+        <p:txBody>
+          <a:bodyPr wrap="none">
+            <a:spAutoFit/>
+          </a:bodyPr>
+          <a:lstStyle/>
+          <a:p>
+            <a:pPr algn="ctr">
+              <a:defRPr sz="3600" b="1">
+                <a:solidFill>
+                  <a:srgbClr val="5856D6"/>
+                </a:solidFill>
+              </a:defRPr>
+            </a:pPr>
+            <a:r>
+              <a:t>KEY BENEFITS</a:t>
+            </a:r>
+          </a:p>
+        </p:txBody>
+      </p:sp>
+      <p:sp>
+        <p:nvSpPr>
+          <p:cNvPr id="4" name="TextBox 3"/>
+          <p:cNvSpPr txBox="1"/>
+          <p:nvPr/>
+        </p:nvSpPr>
+        <p:spPr>
+          <a:xfrm>
+            <a:off x="1371600" y="1645920"/>
+            <a:ext cx="548640" cy="548640"/>
+          </a:xfrm>
+          <a:prstGeom prst="rect">
+            <a:avLst/>
+          </a:prstGeom>
+          <a:noFill/>
+        </p:spPr>
+        <p:txBody>
+          <a:bodyPr wrap="none" anchor="ctr">
+            <a:spAutoFit/>
+          </a:bodyPr>
+          <a:lstStyle/>
+          <a:p>
+            <a:pPr algn="ctr">
+              <a:defRPr sz="2800"/>
+            </a:pPr>
+            <a:r>
+              <a:t>⚡</a:t>
+            </a:r>
+          </a:p>
+        </p:txBody>
+      </p:sp>
+      <p:sp>
+        <p:nvSpPr>
+          <p:cNvPr id="5" name="TextBox 4"/>
+          <p:cNvSpPr txBox="1"/>
+          <p:nvPr/>
+        </p:nvSpPr>
+        <p:spPr>
+          <a:xfrm>
+            <a:off x="2103120" y="1691640"/>
+            <a:ext cx="2286000" cy="274320"/>
+          </a:xfrm>
+          <a:prstGeom prst="rect">
+            <a:avLst/>
+          </a:prstGeom>
+          <a:noFill/>
+        </p:spPr>
+        <p:txBody>
+          <a:bodyPr wrap="none">
+            <a:spAutoFit/>
+          </a:bodyPr>
+          <a:lstStyle/>
+          <a:p>
+            <a:pPr>
+              <a:defRPr sz="1600" b="1">
+                <a:solidFill>
+                  <a:srgbClr val="5856D6"/>
+                </a:solidFill>
+              </a:defRPr>
+            </a:pPr>
+            <a:r>
+              <a:t>Faster Decision Making</a:t>
+            </a:r>
+          </a:p>
+        </p:txBody>
+      </p:sp>
+      <p:sp>
+        <p:nvSpPr>
+          <p:cNvPr id="6" name="TextBox 5"/>
+          <p:cNvSpPr txBox="1"/>
+          <p:nvPr/>
+        </p:nvSpPr>
+        <p:spPr>
+          <a:xfrm>
+            <a:off x="2103120" y="1965960"/>
+            <a:ext cx="5486400" cy="274320"/>
+          </a:xfrm>
+          <a:prstGeom prst="rect">
+            <a:avLst/>
+          </a:prstGeom>
+          <a:noFill/>
+        </p:spPr>
+        <p:txBody>
+          <a:bodyPr wrap="square">
+            <a:spAutoFit/>
+          </a:bodyPr>
+          <a:lstStyle/>
+          <a:p>
+            <a:pPr>
+              <a:defRPr sz="1200">
+                <a:solidFill>
+                  <a:srgbClr val="2D3748"/>
+                </a:solidFill>
+              </a:defRPr>
+            </a:pPr>
+            <a:r>
+              <a:t>Quick access to relevant information across departments</a:t>
+            </a:r>
+          </a:p>
+        </p:txBody>
+      </p:sp>
+      <p:sp>
+        <p:nvSpPr>
+          <p:cNvPr id="7" name="TextBox 6"/>
+          <p:cNvSpPr txBox="1"/>
+          <p:nvPr/>
+        </p:nvSpPr>
+        <p:spPr>
+          <a:xfrm>
+            <a:off x="1371600" y="2377440"/>
+            <a:ext cx="548640" cy="548640"/>
+          </a:xfrm>
+          <a:prstGeom prst="rect">
+            <a:avLst/>
+          </a:prstGeom>
+          <a:noFill/>
+        </p:spPr>
+        <p:txBody>
+          <a:bodyPr wrap="none" anchor="ctr">
+            <a:spAutoFit/>
+          </a:bodyPr>
+          <a:lstStyle/>
+          <a:p>
+            <a:pPr algn="ctr">
+              <a:defRPr sz="2800"/>
+            </a:pPr>
+            <a:r>
+              <a:t>🔒</a:t>
+            </a:r>
+          </a:p>
+        </p:txBody>
+      </p:sp>
+      <p:sp>
+        <p:nvSpPr>
+          <p:cNvPr id="8" name="TextBox 7"/>
+          <p:cNvSpPr txBox="1"/>
+          <p:nvPr/>
+        </p:nvSpPr>
+        <p:spPr>
+          <a:xfrm>
+            <a:off x="2103120" y="2423160"/>
+            <a:ext cx="2286000" cy="274320"/>
+          </a:xfrm>
+          <a:prstGeom prst="rect">
+            <a:avLst/>
+          </a:prstGeom>
+          <a:noFill/>
+        </p:spPr>
+        <p:txBody>
+          <a:bodyPr wrap="none">
+            <a:spAutoFit/>
+          </a:bodyPr>
+          <a:lstStyle/>
+          <a:p>
+            <a:pPr>
+              <a:defRPr sz="1600" b="1">
+                <a:solidFill>
+                  <a:srgbClr val="5856D6"/>
+                </a:solidFill>
+              </a:defRPr>
+            </a:pPr>
+            <a:r>
+              <a:t>Enhanced Security</a:t>
+            </a:r>
+          </a:p>
+        </p:txBody>
+      </p:sp>
+      <p:sp>
+        <p:nvSpPr>
+          <p:cNvPr id="9" name="TextBox 8"/>
+          <p:cNvSpPr txBox="1"/>
+          <p:nvPr/>
+        </p:nvSpPr>
+        <p:spPr>
+          <a:xfrm>
+            <a:off x="2103120" y="2697480"/>
+            <a:ext cx="5486400" cy="274320"/>
+          </a:xfrm>
+          <a:prstGeom prst="rect">
+            <a:avLst/>
+          </a:prstGeom>
+          <a:noFill/>
+        </p:spPr>
+        <p:txBody>
+          <a:bodyPr wrap="square">
+            <a:spAutoFit/>
+          </a:bodyPr>
+          <a:lstStyle/>
+          <a:p>
+            <a:pPr>
+              <a:defRPr sz="1200">
+                <a:solidFill>
+                  <a:srgbClr val="2D3748"/>
+                </a:solidFill>
+              </a:defRPr>
+            </a:pPr>
+            <a:r>
+              <a:t>Granular access control prevents data leaks</a:t>
+            </a:r>
+          </a:p>
+        </p:txBody>
+      </p:sp>
+      <p:sp>
+        <p:nvSpPr>
+          <p:cNvPr id="10" name="TextBox 9"/>
+          <p:cNvSpPr txBox="1"/>
+          <p:nvPr/>
+        </p:nvSpPr>
+        <p:spPr>
+          <a:xfrm>
+            <a:off x="1371600" y="3108960"/>
+            <a:ext cx="548640" cy="548640"/>
+          </a:xfrm>
+          <a:prstGeom prst="rect">
+            <a:avLst/>
+          </a:prstGeom>
+          <a:noFill/>
+        </p:spPr>
+        <p:txBody>
+          <a:bodyPr wrap="none" anchor="ctr">
+            <a:spAutoFit/>
+          </a:bodyPr>
+          <a:lstStyle/>
+          <a:p>
+            <a:pPr algn="ctr">
+              <a:defRPr sz="2800"/>
+            </a:pPr>
+            <a:r>
+              <a:t>💰</a:t>
+            </a:r>
+          </a:p>
+        </p:txBody>
+      </p:sp>
+      <p:sp>
+        <p:nvSpPr>
+          <p:cNvPr id="11" name="TextBox 10"/>
+          <p:cNvSpPr txBox="1"/>
+          <p:nvPr/>
+        </p:nvSpPr>
+        <p:spPr>
+          <a:xfrm>
+            <a:off x="2103120" y="3154680"/>
+            <a:ext cx="2286000" cy="274320"/>
+          </a:xfrm>
+          <a:prstGeom prst="rect">
+            <a:avLst/>
+          </a:prstGeom>
+          <a:noFill/>
+        </p:spPr>
+        <p:txBody>
+          <a:bodyPr wrap="none">
+            <a:spAutoFit/>
+          </a:bodyPr>
+          <a:lstStyle/>
+          <a:p>
+            <a:pPr>
+              <a:defRPr sz="1600" b="1">
+                <a:solidFill>
+                  <a:srgbClr val="5856D6"/>
+                </a:solidFill>
+              </a:defRPr>
+            </a:pPr>
+            <a:r>
+              <a:t>Cost Effective</a:t>
+            </a:r>
+          </a:p>
+        </p:txBody>
+      </p:sp>
+      <p:sp>
+        <p:nvSpPr>
+          <p:cNvPr id="12" name="TextBox 11"/>
+          <p:cNvSpPr txBox="1"/>
+          <p:nvPr/>
+        </p:nvSpPr>
+        <p:spPr>
+          <a:xfrm>
+            <a:off x="2103120" y="3429000"/>
+            <a:ext cx="5486400" cy="274320"/>
+          </a:xfrm>
+          <a:prstGeom prst="rect">
+            <a:avLst/>
+          </a:prstGeom>
+          <a:noFill/>
+        </p:spPr>
+        <p:txBody>
+          <a:bodyPr wrap="square">
+            <a:spAutoFit/>
+          </a:bodyPr>
+          <a:lstStyle/>
+          <a:p>
+            <a:pPr>
+              <a:defRPr sz="1200">
+                <a:solidFill>
+                  <a:srgbClr val="2D3748"/>
+                </a:solidFill>
+              </a:defRPr>
+            </a:pPr>
+            <a:r>
+              <a:t>Reduces time spent searching for information</a:t>
+            </a:r>
+          </a:p>
+        </p:txBody>
+      </p:sp>
+      <p:sp>
+        <p:nvSpPr>
+          <p:cNvPr id="13" name="TextBox 12"/>
+          <p:cNvSpPr txBox="1"/>
+          <p:nvPr/>
+        </p:nvSpPr>
+        <p:spPr>
+          <a:xfrm>
+            <a:off x="1371600" y="3840480"/>
+            <a:ext cx="548640" cy="548640"/>
+          </a:xfrm>
+          <a:prstGeom prst="rect">
+            <a:avLst/>
+          </a:prstGeom>
+          <a:noFill/>
+        </p:spPr>
+        <p:txBody>
+          <a:bodyPr wrap="none" anchor="ctr">
+            <a:spAutoFit/>
+          </a:bodyPr>
+          <a:lstStyle/>
+          <a:p>
+            <a:pPr algn="ctr">
+              <a:defRPr sz="2800"/>
+            </a:pPr>
+            <a:r>
+              <a:t>📈</a:t>
+            </a:r>
+          </a:p>
+        </p:txBody>
+      </p:sp>
+      <p:sp>
+        <p:nvSpPr>
+          <p:cNvPr id="14" name="TextBox 13"/>
+          <p:cNvSpPr txBox="1"/>
+          <p:nvPr/>
+        </p:nvSpPr>
+        <p:spPr>
+          <a:xfrm>
+            <a:off x="2103120" y="3886200"/>
+            <a:ext cx="2286000" cy="274320"/>
+          </a:xfrm>
+          <a:prstGeom prst="rect">
+            <a:avLst/>
+          </a:prstGeom>
+          <a:noFill/>
+        </p:spPr>
+        <p:txBody>
+          <a:bodyPr wrap="none">
+            <a:spAutoFit/>
+          </a:bodyPr>
+          <a:lstStyle/>
+          <a:p>
+            <a:pPr>
+              <a:defRPr sz="1600" b="1">
+                <a:solidFill>
+                  <a:srgbClr val="5856D6"/>
+                </a:solidFill>
+              </a:defRPr>
+            </a:pPr>
+            <a:r>
+              <a:t>Improved Productivity</a:t>
+            </a:r>
+          </a:p>
+        </p:txBody>
+      </p:sp>
+      <p:sp>
+        <p:nvSpPr>
+          <p:cNvPr id="15" name="TextBox 14"/>
+          <p:cNvSpPr txBox="1"/>
+          <p:nvPr/>
+        </p:nvSpPr>
+        <p:spPr>
+          <a:xfrm>
+            <a:off x="2103120" y="4160520"/>
+            <a:ext cx="5486400" cy="274320"/>
+          </a:xfrm>
+          <a:prstGeom prst="rect">
+            <a:avLst/>
+          </a:prstGeom>
+          <a:noFill/>
+        </p:spPr>
+        <p:txBody>
+          <a:bodyPr wrap="square">
+            <a:spAutoFit/>
+          </a:bodyPr>
+          <a:lstStyle/>
+          <a:p>
+            <a:pPr>
+              <a:defRPr sz="1200">
+                <a:solidFill>
+                  <a:srgbClr val="2D3748"/>
+                </a:solidFill>
+              </a:defRPr>
+            </a:pPr>
+            <a:r>
+              <a:t>Employees find answers instantly without manual search</a:t>
+            </a:r>
+          </a:p>
+        </p:txBody>
+      </p:sp>
+      <p:sp>
+        <p:nvSpPr>
+          <p:cNvPr id="16" name="TextBox 15"/>
+          <p:cNvSpPr txBox="1"/>
+          <p:nvPr/>
+        </p:nvSpPr>
+        <p:spPr>
+          <a:xfrm>
+            <a:off x="1371600" y="4572000"/>
+            <a:ext cx="548640" cy="548640"/>
+          </a:xfrm>
+          <a:prstGeom prst="rect">
+            <a:avLst/>
+          </a:prstGeom>
+          <a:noFill/>
+        </p:spPr>
+        <p:txBody>
+          <a:bodyPr wrap="none" anchor="ctr">
+            <a:spAutoFit/>
+          </a:bodyPr>
+          <a:lstStyle/>
+          <a:p>
+            <a:pPr algn="ctr">
+              <a:defRPr sz="2800"/>
+            </a:pPr>
+            <a:r>
+              <a:t>🎯</a:t>
+            </a:r>
+          </a:p>
+        </p:txBody>
+      </p:sp>
+      <p:sp>
+        <p:nvSpPr>
+          <p:cNvPr id="17" name="TextBox 16"/>
+          <p:cNvSpPr txBox="1"/>
+          <p:nvPr/>
+        </p:nvSpPr>
+        <p:spPr>
+          <a:xfrm>
+            <a:off x="2103120" y="4617720"/>
+            <a:ext cx="2286000" cy="274320"/>
+          </a:xfrm>
+          <a:prstGeom prst="rect">
+            <a:avLst/>
+          </a:prstGeom>
+          <a:noFill/>
+        </p:spPr>
+        <p:txBody>
+          <a:bodyPr wrap="none">
+            <a:spAutoFit/>
+          </a:bodyPr>
+          <a:lstStyle/>
+          <a:p>
+            <a:pPr>
+              <a:defRPr sz="1600" b="1">
+                <a:solidFill>
+                  <a:srgbClr val="5856D6"/>
+                </a:solidFill>
+              </a:defRPr>
+            </a:pPr>
+            <a:r>
+              <a:t>Accurate Responses</a:t>
+            </a:r>
+          </a:p>
+        </p:txBody>
+      </p:sp>
+      <p:sp>
+        <p:nvSpPr>
+          <p:cNvPr id="18" name="TextBox 17"/>
+          <p:cNvSpPr txBox="1"/>
+          <p:nvPr/>
+        </p:nvSpPr>
+        <p:spPr>
+          <a:xfrm>
+            <a:off x="2103120" y="4892040"/>
+            <a:ext cx="5486400" cy="274320"/>
+          </a:xfrm>
+          <a:prstGeom prst="rect">
+            <a:avLst/>
+          </a:prstGeom>
+          <a:noFill/>
+        </p:spPr>
+        <p:txBody>
+          <a:bodyPr wrap="square">
+            <a:spAutoFit/>
+          </a:bodyPr>
+          <a:lstStyle/>
+          <a:p>
+            <a:pPr>
+              <a:defRPr sz="1200">
+                <a:solidFill>
+                  <a:srgbClr val="2D3748"/>
+                </a:solidFill>
+              </a:defRPr>
+            </a:pPr>
+            <a:r>
+              <a:t>AI-powered semantic understanding with source citations</a:t>
+            </a:r>
+          </a:p>
+        </p:txBody>
+      </p:sp>
+      <p:sp>
+        <p:nvSpPr>
+          <p:cNvPr id="19" name="TextBox 18"/>
+          <p:cNvSpPr txBox="1"/>
+          <p:nvPr/>
+        </p:nvSpPr>
+        <p:spPr>
+          <a:xfrm>
+            <a:off x="1371600" y="5303520"/>
+            <a:ext cx="548640" cy="548640"/>
+          </a:xfrm>
+          <a:prstGeom prst="rect">
+            <a:avLst/>
+          </a:prstGeom>
+          <a:noFill/>
+        </p:spPr>
+        <p:txBody>
+          <a:bodyPr wrap="none" anchor="ctr">
+            <a:spAutoFit/>
+          </a:bodyPr>
+          <a:lstStyle/>
+          <a:p>
+            <a:pPr algn="ctr">
+              <a:defRPr sz="2800"/>
+            </a:pPr>
+            <a:r>
+              <a:t>🔄</a:t>
+            </a:r>
+          </a:p>
+        </p:txBody>
+      </p:sp>
+      <p:sp>
+        <p:nvSpPr>
+          <p:cNvPr id="20" name="TextBox 19"/>
+          <p:cNvSpPr txBox="1"/>
+          <p:nvPr/>
+        </p:nvSpPr>
+        <p:spPr>
+          <a:xfrm>
+            <a:off x="2103120" y="5349240"/>
+            <a:ext cx="2286000" cy="274320"/>
+          </a:xfrm>
+          <a:prstGeom prst="rect">
+            <a:avLst/>
+          </a:prstGeom>
+          <a:noFill/>
+        </p:spPr>
+        <p:txBody>
+          <a:bodyPr wrap="none">
+            <a:spAutoFit/>
+          </a:bodyPr>
+          <a:lstStyle/>
+          <a:p>
+            <a:pPr>
+              <a:defRPr sz="1600" b="1">
+                <a:solidFill>
+                  <a:srgbClr val="5856D6"/>
+                </a:solidFill>
+              </a:defRPr>
+            </a:pPr>
+            <a:r>
+              <a:t>Easy Scalability</a:t>
+            </a:r>
+          </a:p>
+        </p:txBody>
+      </p:sp>
+      <p:sp>
+        <p:nvSpPr>
+          <p:cNvPr id="21" name="TextBox 20"/>
+          <p:cNvSpPr txBox="1"/>
+          <p:nvPr/>
+        </p:nvSpPr>
+        <p:spPr>
+          <a:xfrm>
+            <a:off x="2103120" y="5623559"/>
+            <a:ext cx="5486400" cy="274320"/>
+          </a:xfrm>
+          <a:prstGeom prst="rect">
+            <a:avLst/>
+          </a:prstGeom>
+          <a:noFill/>
+        </p:spPr>
+        <p:txBody>
+          <a:bodyPr wrap="square">
+            <a:spAutoFit/>
+          </a:bodyPr>
+          <a:lstStyle/>
+          <a:p>
+            <a:pPr>
+              <a:defRPr sz="1200">
+                <a:solidFill>
+                  <a:srgbClr val="2D3748"/>
+                </a:solidFill>
+              </a:defRPr>
+            </a:pPr>
+            <a:r>
+              <a:t>Add new documents and departments effortlessly</a:t>
+            </a:r>
+          </a:p>
+        </p:txBody>
+      </p:sp>
+    </p:spTree>
+  </p:cSld>
+  <p:clrMapOvr>
+    <a:masterClrMapping/>
+  </p:clrMapOvr>
+</p:sld>
+</file>
+
+<file path=ppt/slides/slide14.xml><?xml version="1.0" encoding="utf-8"?>
+<p:sld xmlns:a="http://schemas.openxmlformats.org/drawingml/2006/main" xmlns:p="http://schemas.openxmlformats.org/presentationml/2006/main" xmlns:r="http://schemas.openxmlformats.org/officeDocument/2006/relationships">
+  <p:cSld>
+    <p:spTree>
+      <p:nvGrpSpPr>
+        <p:cNvPr id="1" name=""/>
+        <p:cNvGrpSpPr/>
+        <p:nvPr/>
+      </p:nvGrpSpPr>
+      <p:grpSpPr/>
+      <p:sp>
+        <p:nvSpPr>
+          <p:cNvPr id="2" name="Rectangle 1"/>
+          <p:cNvSpPr/>
+          <p:nvPr/>
+        </p:nvSpPr>
+        <p:spPr>
+          <a:xfrm>
+            <a:off x="0" y="0"/>
+            <a:ext cx="9144000" cy="6858000"/>
+          </a:xfrm>
+          <a:prstGeom prst="rect">
+            <a:avLst/>
+          </a:prstGeom>
+          <a:solidFill>
+            <a:srgbClr val="F8FAFC"/>
+          </a:solidFill>
+          <a:ln>
+            <a:noFill/>
+          </a:ln>
+        </p:spPr>
+        <p:style>
+          <a:lnRef idx="1">
+            <a:schemeClr val="accent1"/>
+          </a:lnRef>
+          <a:fillRef idx="3">
+            <a:schemeClr val="accent1"/>
+          </a:fillRef>
+          <a:effectRef idx="2">
+            <a:schemeClr val="accent1"/>
+          </a:effectRef>
+          <a:fontRef idx="minor">
+            <a:schemeClr val="lt1"/>
+          </a:fontRef>
+        </p:style>
+        <p:txBody>
+          <a:bodyPr rtlCol="0" anchor="ctr"/>
+          <a:lstStyle/>
+          <a:p>
+            <a:pPr algn="ctr"/>
+          </a:p>
+        </p:txBody>
+      </p:sp>
+      <p:sp>
+        <p:nvSpPr>
+          <p:cNvPr id="3" name="TextBox 2"/>
+          <p:cNvSpPr txBox="1"/>
+          <p:nvPr/>
+        </p:nvSpPr>
+        <p:spPr>
+          <a:xfrm>
+            <a:off x="914400" y="457200"/>
+            <a:ext cx="7315200" cy="731520"/>
+          </a:xfrm>
+          <a:prstGeom prst="rect">
+            <a:avLst/>
+          </a:prstGeom>
+          <a:noFill/>
+        </p:spPr>
+        <p:txBody>
+          <a:bodyPr wrap="none">
+            <a:spAutoFit/>
+          </a:bodyPr>
+          <a:lstStyle/>
+          <a:p>
+            <a:pPr algn="ctr">
+              <a:defRPr sz="3600" b="1">
+                <a:solidFill>
+                  <a:srgbClr val="8A2BE2"/>
+                </a:solidFill>
+              </a:defRPr>
+            </a:pPr>
+            <a:r>
+              <a:t>FUTURE ENHANCEMENTS</a:t>
+            </a:r>
+          </a:p>
+        </p:txBody>
+      </p:sp>
+      <p:sp>
+        <p:nvSpPr>
+          <p:cNvPr id="4" name="Rounded Rectangle 3"/>
+          <p:cNvSpPr/>
+          <p:nvPr/>
+        </p:nvSpPr>
+        <p:spPr>
+          <a:xfrm>
+            <a:off x="1371600" y="1645920"/>
+            <a:ext cx="6400800" cy="685800"/>
+          </a:xfrm>
+          <a:prstGeom prst="roundRect">
+            <a:avLst/>
+          </a:prstGeom>
+          <a:solidFill>
+            <a:srgbClr val="FFFFFF"/>
+          </a:solidFill>
+          <a:ln w="25400">
+            <a:solidFill>
+              <a:srgbClr val="5856D6"/>
+            </a:solidFill>
+          </a:ln>
+        </p:spPr>
+        <p:style>
+          <a:lnRef idx="1">
+            <a:schemeClr val="accent1"/>
+          </a:lnRef>
+          <a:fillRef idx="3">
+            <a:schemeClr val="accent1"/>
+          </a:fillRef>
+          <a:effectRef idx="2">
+            <a:schemeClr val="accent1"/>
+          </a:effectRef>
+          <a:fontRef idx="minor">
+            <a:schemeClr val="lt1"/>
+          </a:fontRef>
+        </p:style>
+        <p:txBody>
+          <a:bodyPr rtlCol="0" anchor="ctr"/>
+          <a:lstStyle/>
+          <a:p>
+            <a:pPr algn="ctr"/>
+          </a:p>
+        </p:txBody>
+      </p:sp>
+      <p:sp>
+        <p:nvSpPr>
+          <p:cNvPr id="5" name="TextBox 4"/>
+          <p:cNvSpPr txBox="1"/>
+          <p:nvPr/>
+        </p:nvSpPr>
+        <p:spPr>
+          <a:xfrm>
+            <a:off x="1828800" y="1783080"/>
+            <a:ext cx="2743200" cy="228600"/>
+          </a:xfrm>
+          <a:prstGeom prst="rect">
+            <a:avLst/>
+          </a:prstGeom>
+          <a:noFill/>
+        </p:spPr>
+        <p:txBody>
+          <a:bodyPr wrap="none">
+            <a:spAutoFit/>
+          </a:bodyPr>
+          <a:lstStyle/>
+          <a:p>
+            <a:pPr>
+              <a:defRPr sz="1500" b="1">
+                <a:solidFill>
+                  <a:srgbClr val="5856D6"/>
+                </a:solidFill>
+              </a:defRPr>
+            </a:pPr>
+            <a:r>
+              <a:t>Multi-language Support</a:t>
+            </a:r>
+          </a:p>
+        </p:txBody>
+      </p:sp>
+      <p:sp>
+        <p:nvSpPr>
+          <p:cNvPr id="6" name="TextBox 5"/>
+          <p:cNvSpPr txBox="1"/>
+          <p:nvPr/>
+        </p:nvSpPr>
+        <p:spPr>
+          <a:xfrm>
+            <a:off x="1828800" y="2029968"/>
+            <a:ext cx="5486400" cy="228600"/>
+          </a:xfrm>
+          <a:prstGeom prst="rect">
+            <a:avLst/>
+          </a:prstGeom>
+          <a:noFill/>
+        </p:spPr>
+        <p:txBody>
+          <a:bodyPr wrap="square">
+            <a:spAutoFit/>
+          </a:bodyPr>
+          <a:lstStyle/>
+          <a:p>
+            <a:pPr>
+              <a:defRPr sz="1100">
+                <a:solidFill>
+                  <a:srgbClr val="2D3748"/>
+                </a:solidFill>
+              </a:defRPr>
+            </a:pPr>
+            <a:r>
+              <a:t>Support for multiple languages in queries and documents</a:t>
+            </a:r>
+          </a:p>
+        </p:txBody>
+      </p:sp>
+      <p:sp>
+        <p:nvSpPr>
+          <p:cNvPr id="7" name="Rounded Rectangle 6"/>
+          <p:cNvSpPr/>
+          <p:nvPr/>
+        </p:nvSpPr>
+        <p:spPr>
+          <a:xfrm>
+            <a:off x="1371600" y="2468880"/>
+            <a:ext cx="6400800" cy="685800"/>
+          </a:xfrm>
+          <a:prstGeom prst="roundRect">
+            <a:avLst/>
+          </a:prstGeom>
+          <a:solidFill>
+            <a:srgbClr val="FFFFFF"/>
+          </a:solidFill>
+          <a:ln w="25400">
+            <a:solidFill>
+              <a:srgbClr val="FF4785"/>
+            </a:solidFill>
+          </a:ln>
+        </p:spPr>
+        <p:style>
+          <a:lnRef idx="1">
+            <a:schemeClr val="accent1"/>
+          </a:lnRef>
+          <a:fillRef idx="3">
+            <a:schemeClr val="accent1"/>
+          </a:fillRef>
+          <a:effectRef idx="2">
+            <a:schemeClr val="accent1"/>
+          </a:effectRef>
+          <a:fontRef idx="minor">
+            <a:schemeClr val="lt1"/>
+          </a:fontRef>
+        </p:style>
+        <p:txBody>
+          <a:bodyPr rtlCol="0" anchor="ctr"/>
+          <a:lstStyle/>
+          <a:p>
+            <a:pPr algn="ctr"/>
+          </a:p>
+        </p:txBody>
+      </p:sp>
+      <p:sp>
+        <p:nvSpPr>
+          <p:cNvPr id="8" name="TextBox 7"/>
+          <p:cNvSpPr txBox="1"/>
+          <p:nvPr/>
+        </p:nvSpPr>
+        <p:spPr>
+          <a:xfrm>
+            <a:off x="1828800" y="2606040"/>
+            <a:ext cx="2743200" cy="228600"/>
+          </a:xfrm>
+          <a:prstGeom prst="rect">
+            <a:avLst/>
+          </a:prstGeom>
+          <a:noFill/>
+        </p:spPr>
+        <p:txBody>
+          <a:bodyPr wrap="none">
+            <a:spAutoFit/>
+          </a:bodyPr>
+          <a:lstStyle/>
+          <a:p>
+            <a:pPr>
+              <a:defRPr sz="1500" b="1">
+                <a:solidFill>
+                  <a:srgbClr val="FF4785"/>
+                </a:solidFill>
+              </a:defRPr>
+            </a:pPr>
+            <a:r>
+              <a:t>Voice Integration</a:t>
+            </a:r>
+          </a:p>
+        </p:txBody>
+      </p:sp>
+      <p:sp>
+        <p:nvSpPr>
+          <p:cNvPr id="9" name="TextBox 8"/>
+          <p:cNvSpPr txBox="1"/>
+          <p:nvPr/>
+        </p:nvSpPr>
+        <p:spPr>
+          <a:xfrm>
+            <a:off x="1828800" y="2852928"/>
+            <a:ext cx="5486400" cy="228600"/>
+          </a:xfrm>
+          <a:prstGeom prst="rect">
+            <a:avLst/>
+          </a:prstGeom>
+          <a:noFill/>
+        </p:spPr>
+        <p:txBody>
+          <a:bodyPr wrap="square">
+            <a:spAutoFit/>
+          </a:bodyPr>
+          <a:lstStyle/>
+          <a:p>
+            <a:pPr>
+              <a:defRPr sz="1100">
+                <a:solidFill>
+                  <a:srgbClr val="2D3748"/>
+                </a:solidFill>
+              </a:defRPr>
+            </a:pPr>
+            <a:r>
+              <a:t>Voice-based query input and audio responses</a:t>
+            </a:r>
+          </a:p>
+        </p:txBody>
+      </p:sp>
+      <p:sp>
+        <p:nvSpPr>
+          <p:cNvPr id="10" name="Rounded Rectangle 9"/>
+          <p:cNvSpPr/>
+          <p:nvPr/>
+        </p:nvSpPr>
+        <p:spPr>
+          <a:xfrm>
+            <a:off x="1371600" y="3291840"/>
+            <a:ext cx="6400800" cy="685800"/>
+          </a:xfrm>
+          <a:prstGeom prst="roundRect">
+            <a:avLst/>
+          </a:prstGeom>
+          <a:solidFill>
+            <a:srgbClr val="FFFFFF"/>
+          </a:solidFill>
+          <a:ln w="25400">
+            <a:solidFill>
+              <a:srgbClr val="2ED573"/>
+            </a:solidFill>
+          </a:ln>
+        </p:spPr>
+        <p:style>
+          <a:lnRef idx="1">
+            <a:schemeClr val="accent1"/>
+          </a:lnRef>
+          <a:fillRef idx="3">
+            <a:schemeClr val="accent1"/>
+          </a:fillRef>
+          <a:effectRef idx="2">
+            <a:schemeClr val="accent1"/>
+          </a:effectRef>
+          <a:fontRef idx="minor">
+            <a:schemeClr val="lt1"/>
+          </a:fontRef>
+        </p:style>
+        <p:txBody>
+          <a:bodyPr rtlCol="0" anchor="ctr"/>
+          <a:lstStyle/>
+          <a:p>
+            <a:pPr algn="ctr"/>
+          </a:p>
+        </p:txBody>
+      </p:sp>
+      <p:sp>
+        <p:nvSpPr>
+          <p:cNvPr id="11" name="TextBox 10"/>
+          <p:cNvSpPr txBox="1"/>
+          <p:nvPr/>
+        </p:nvSpPr>
+        <p:spPr>
+          <a:xfrm>
+            <a:off x="1828800" y="3429000"/>
+            <a:ext cx="2743200" cy="228600"/>
+          </a:xfrm>
+          <a:prstGeom prst="rect">
+            <a:avLst/>
+          </a:prstGeom>
+          <a:noFill/>
+        </p:spPr>
+        <p:txBody>
+          <a:bodyPr wrap="none">
+            <a:spAutoFit/>
+          </a:bodyPr>
+          <a:lstStyle/>
+          <a:p>
+            <a:pPr>
+              <a:defRPr sz="1500" b="1">
+                <a:solidFill>
+                  <a:srgbClr val="2ED573"/>
+                </a:solidFill>
+              </a:defRPr>
+            </a:pPr>
+            <a:r>
+              <a:t>Advanced Analytics</a:t>
+            </a:r>
+          </a:p>
+        </p:txBody>
+      </p:sp>
+      <p:sp>
+        <p:nvSpPr>
+          <p:cNvPr id="12" name="TextBox 11"/>
+          <p:cNvSpPr txBox="1"/>
+          <p:nvPr/>
+        </p:nvSpPr>
+        <p:spPr>
+          <a:xfrm>
+            <a:off x="1828800" y="3675888"/>
+            <a:ext cx="5486400" cy="228600"/>
+          </a:xfrm>
+          <a:prstGeom prst="rect">
+            <a:avLst/>
+          </a:prstGeom>
+          <a:noFill/>
+        </p:spPr>
+        <p:txBody>
+          <a:bodyPr wrap="square">
+            <a:spAutoFit/>
+          </a:bodyPr>
+          <a:lstStyle/>
+          <a:p>
+            <a:pPr>
+              <a:defRPr sz="1100">
+                <a:solidFill>
+                  <a:srgbClr val="2D3748"/>
+                </a:solidFill>
+              </a:defRPr>
+            </a:pPr>
+            <a:r>
+              <a:t>Query analytics and usage patterns dashboard</a:t>
+            </a:r>
+          </a:p>
+        </p:txBody>
+      </p:sp>
+      <p:sp>
+        <p:nvSpPr>
+          <p:cNvPr id="13" name="Rounded Rectangle 12"/>
+          <p:cNvSpPr/>
+          <p:nvPr/>
+        </p:nvSpPr>
+        <p:spPr>
+          <a:xfrm>
+            <a:off x="1371600" y="4114800"/>
+            <a:ext cx="6400800" cy="685800"/>
+          </a:xfrm>
+          <a:prstGeom prst="roundRect">
+            <a:avLst/>
+          </a:prstGeom>
+          <a:solidFill>
+            <a:srgbClr val="FFFFFF"/>
+          </a:solidFill>
+          <a:ln w="25400">
+            <a:solidFill>
+              <a:srgbClr val="FF8C00"/>
+            </a:solidFill>
+          </a:ln>
+        </p:spPr>
+        <p:style>
+          <a:lnRef idx="1">
+            <a:schemeClr val="accent1"/>
+          </a:lnRef>
+          <a:fillRef idx="3">
+            <a:schemeClr val="accent1"/>
+          </a:fillRef>
+          <a:effectRef idx="2">
+            <a:schemeClr val="accent1"/>
+          </a:effectRef>
+          <a:fontRef idx="minor">
+            <a:schemeClr val="lt1"/>
+          </a:fontRef>
+        </p:style>
+        <p:txBody>
+          <a:bodyPr rtlCol="0" anchor="ctr"/>
+          <a:lstStyle/>
+          <a:p>
+            <a:pPr algn="ctr"/>
+          </a:p>
+        </p:txBody>
+      </p:sp>
+      <p:sp>
+        <p:nvSpPr>
+          <p:cNvPr id="14" name="TextBox 13"/>
+          <p:cNvSpPr txBox="1"/>
+          <p:nvPr/>
+        </p:nvSpPr>
+        <p:spPr>
+          <a:xfrm>
+            <a:off x="1828800" y="4251960"/>
+            <a:ext cx="2743200" cy="228600"/>
+          </a:xfrm>
+          <a:prstGeom prst="rect">
+            <a:avLst/>
+          </a:prstGeom>
+          <a:noFill/>
+        </p:spPr>
+        <p:txBody>
+          <a:bodyPr wrap="none">
+            <a:spAutoFit/>
+          </a:bodyPr>
+          <a:lstStyle/>
+          <a:p>
+            <a:pPr>
+              <a:defRPr sz="1500" b="1">
+                <a:solidFill>
+                  <a:srgbClr val="FF8C00"/>
+                </a:solidFill>
+              </a:defRPr>
+            </a:pPr>
+            <a:r>
+              <a:t>Document Versioning</a:t>
+            </a:r>
+          </a:p>
+        </p:txBody>
+      </p:sp>
+      <p:sp>
+        <p:nvSpPr>
+          <p:cNvPr id="15" name="TextBox 14"/>
+          <p:cNvSpPr txBox="1"/>
+          <p:nvPr/>
+        </p:nvSpPr>
+        <p:spPr>
+          <a:xfrm>
+            <a:off x="1828800" y="4498848"/>
+            <a:ext cx="5486400" cy="228600"/>
+          </a:xfrm>
+          <a:prstGeom prst="rect">
+            <a:avLst/>
+          </a:prstGeom>
+          <a:noFill/>
+        </p:spPr>
+        <p:txBody>
+          <a:bodyPr wrap="square">
+            <a:spAutoFit/>
+          </a:bodyPr>
+          <a:lstStyle/>
+          <a:p>
+            <a:pPr>
+              <a:defRPr sz="1100">
+                <a:solidFill>
+                  <a:srgbClr val="2D3748"/>
+                </a:solidFill>
+              </a:defRPr>
+            </a:pPr>
+            <a:r>
+              <a:t>Track document changes and maintain version history</a:t>
+            </a:r>
+          </a:p>
+        </p:txBody>
+      </p:sp>
+      <p:sp>
+        <p:nvSpPr>
+          <p:cNvPr id="16" name="Rounded Rectangle 15"/>
+          <p:cNvSpPr/>
+          <p:nvPr/>
+        </p:nvSpPr>
+        <p:spPr>
+          <a:xfrm>
+            <a:off x="1371600" y="4937760"/>
+            <a:ext cx="6400800" cy="685800"/>
+          </a:xfrm>
+          <a:prstGeom prst="roundRect">
+            <a:avLst/>
+          </a:prstGeom>
+          <a:solidFill>
+            <a:srgbClr val="FFFFFF"/>
+          </a:solidFill>
+          <a:ln w="25400">
+            <a:solidFill>
+              <a:srgbClr val="8A2BE2"/>
+            </a:solidFill>
+          </a:ln>
+        </p:spPr>
+        <p:style>
+          <a:lnRef idx="1">
+            <a:schemeClr val="accent1"/>
+          </a:lnRef>
+          <a:fillRef idx="3">
+            <a:schemeClr val="accent1"/>
+          </a:fillRef>
+          <a:effectRef idx="2">
+            <a:schemeClr val="accent1"/>
+          </a:effectRef>
+          <a:fontRef idx="minor">
+            <a:schemeClr val="lt1"/>
+          </a:fontRef>
+        </p:style>
+        <p:txBody>
+          <a:bodyPr rtlCol="0" anchor="ctr"/>
+          <a:lstStyle/>
+          <a:p>
+            <a:pPr algn="ctr"/>
+          </a:p>
+        </p:txBody>
+      </p:sp>
+      <p:sp>
+        <p:nvSpPr>
+          <p:cNvPr id="17" name="TextBox 16"/>
+          <p:cNvSpPr txBox="1"/>
+          <p:nvPr/>
+        </p:nvSpPr>
+        <p:spPr>
+          <a:xfrm>
+            <a:off x="1828800" y="5074920"/>
+            <a:ext cx="2743200" cy="228600"/>
+          </a:xfrm>
+          <a:prstGeom prst="rect">
+            <a:avLst/>
+          </a:prstGeom>
+          <a:noFill/>
+        </p:spPr>
+        <p:txBody>
+          <a:bodyPr wrap="none">
+            <a:spAutoFit/>
+          </a:bodyPr>
+          <a:lstStyle/>
+          <a:p>
+            <a:pPr>
+              <a:defRPr sz="1500" b="1">
+                <a:solidFill>
+                  <a:srgbClr val="8A2BE2"/>
+                </a:solidFill>
+              </a:defRPr>
+            </a:pPr>
+            <a:r>
+              <a:t>Mobile Application</a:t>
+            </a:r>
+          </a:p>
+        </p:txBody>
+      </p:sp>
+      <p:sp>
+        <p:nvSpPr>
+          <p:cNvPr id="18" name="TextBox 17"/>
+          <p:cNvSpPr txBox="1"/>
+          <p:nvPr/>
+        </p:nvSpPr>
+        <p:spPr>
+          <a:xfrm>
+            <a:off x="1828800" y="5321808"/>
+            <a:ext cx="5486400" cy="228600"/>
+          </a:xfrm>
+          <a:prstGeom prst="rect">
+            <a:avLst/>
+          </a:prstGeom>
+          <a:noFill/>
+        </p:spPr>
+        <p:txBody>
+          <a:bodyPr wrap="square">
+            <a:spAutoFit/>
+          </a:bodyPr>
+          <a:lstStyle/>
+          <a:p>
+            <a:pPr>
+              <a:defRPr sz="1100">
+                <a:solidFill>
+                  <a:srgbClr val="2D3748"/>
+                </a:solidFill>
+              </a:defRPr>
+            </a:pPr>
+            <a:r>
+              <a:t>Native mobile apps for iOS and Android</a:t>
+            </a:r>
+          </a:p>
+        </p:txBody>
+      </p:sp>
+      <p:sp>
+        <p:nvSpPr>
+          <p:cNvPr id="19" name="Rounded Rectangle 18"/>
+          <p:cNvSpPr/>
+          <p:nvPr/>
+        </p:nvSpPr>
+        <p:spPr>
+          <a:xfrm>
+            <a:off x="1371600" y="5760720"/>
+            <a:ext cx="6400800" cy="685800"/>
+          </a:xfrm>
+          <a:prstGeom prst="roundRect">
+            <a:avLst/>
+          </a:prstGeom>
+          <a:solidFill>
+            <a:srgbClr val="FFFFFF"/>
+          </a:solidFill>
+          <a:ln w="25400">
+            <a:solidFill>
+              <a:srgbClr val="5856D6"/>
+            </a:solidFill>
+          </a:ln>
+        </p:spPr>
+        <p:style>
+          <a:lnRef idx="1">
+            <a:schemeClr val="accent1"/>
+          </a:lnRef>
+          <a:fillRef idx="3">
+            <a:schemeClr val="accent1"/>
+          </a:fillRef>
+          <a:effectRef idx="2">
+            <a:schemeClr val="accent1"/>
+          </a:effectRef>
+          <a:fontRef idx="minor">
+            <a:schemeClr val="lt1"/>
+          </a:fontRef>
+        </p:style>
+        <p:txBody>
+          <a:bodyPr rtlCol="0" anchor="ctr"/>
+          <a:lstStyle/>
+          <a:p>
+            <a:pPr algn="ctr"/>
+          </a:p>
+        </p:txBody>
+      </p:sp>
+      <p:sp>
+        <p:nvSpPr>
+          <p:cNvPr id="20" name="TextBox 19"/>
+          <p:cNvSpPr txBox="1"/>
+          <p:nvPr/>
+        </p:nvSpPr>
+        <p:spPr>
+          <a:xfrm>
+            <a:off x="1828800" y="5897880"/>
+            <a:ext cx="2743200" cy="228600"/>
+          </a:xfrm>
+          <a:prstGeom prst="rect">
+            <a:avLst/>
+          </a:prstGeom>
+          <a:noFill/>
+        </p:spPr>
+        <p:txBody>
+          <a:bodyPr wrap="none">
+            <a:spAutoFit/>
+          </a:bodyPr>
+          <a:lstStyle/>
+          <a:p>
+            <a:pPr>
+              <a:defRPr sz="1500" b="1">
+                <a:solidFill>
+                  <a:srgbClr val="5856D6"/>
+                </a:solidFill>
+              </a:defRPr>
+            </a:pPr>
+            <a:r>
+              <a:t>Integration APIs</a:t>
+            </a:r>
+          </a:p>
+        </p:txBody>
+      </p:sp>
+      <p:sp>
+        <p:nvSpPr>
+          <p:cNvPr id="21" name="TextBox 20"/>
+          <p:cNvSpPr txBox="1"/>
+          <p:nvPr/>
+        </p:nvSpPr>
+        <p:spPr>
+          <a:xfrm>
+            <a:off x="1828800" y="6144768"/>
+            <a:ext cx="5486400" cy="228600"/>
+          </a:xfrm>
+          <a:prstGeom prst="rect">
+            <a:avLst/>
+          </a:prstGeom>
+          <a:noFill/>
+        </p:spPr>
+        <p:txBody>
+          <a:bodyPr wrap="square">
+            <a:spAutoFit/>
+          </a:bodyPr>
+          <a:lstStyle/>
+          <a:p>
+            <a:pPr>
+              <a:defRPr sz="1100">
+                <a:solidFill>
+                  <a:srgbClr val="2D3748"/>
+                </a:solidFill>
+              </a:defRPr>
+            </a:pPr>
+            <a:r>
+              <a:t>Connect with Slack, Teams, and other tools</a:t>
+            </a:r>
+          </a:p>
+        </p:txBody>
+      </p:sp>
+    </p:spTree>
+  </p:cSld>
+  <p:clrMapOvr>
+    <a:masterClrMapping/>
+  </p:clrMapOvr>
+</p:sld>
+</file>
+
+<file path=ppt/slides/slide15.xml><?xml version="1.0" encoding="utf-8"?>
+<p:sld xmlns:a="http://schemas.openxmlformats.org/drawingml/2006/main" xmlns:p="http://schemas.openxmlformats.org/presentationml/2006/main" xmlns:r="http://schemas.openxmlformats.org/officeDocument/2006/relationships">
+  <p:cSld>
+    <p:spTree>
+      <p:nvGrpSpPr>
+        <p:cNvPr id="1" name=""/>
+        <p:cNvGrpSpPr/>
+        <p:nvPr/>
+      </p:nvGrpSpPr>
+      <p:grpSpPr/>
+      <p:sp>
+        <p:nvSpPr>
+          <p:cNvPr id="2" name="Rectangle 1"/>
+          <p:cNvSpPr/>
+          <p:nvPr/>
+        </p:nvSpPr>
+        <p:spPr>
+          <a:xfrm>
+            <a:off x="0" y="0"/>
+            <a:ext cx="9144000" cy="6858000"/>
+          </a:xfrm>
+          <a:prstGeom prst="rect">
+            <a:avLst/>
+          </a:prstGeom>
+          <a:solidFill>
+            <a:srgbClr val="1A202C"/>
+          </a:solidFill>
+          <a:ln>
+            <a:noFill/>
+          </a:ln>
+        </p:spPr>
+        <p:style>
+          <a:lnRef idx="1">
+            <a:schemeClr val="accent1"/>
+          </a:lnRef>
+          <a:fillRef idx="3">
+            <a:schemeClr val="accent1"/>
+          </a:fillRef>
+          <a:effectRef idx="2">
+            <a:schemeClr val="accent1"/>
+          </a:effectRef>
+          <a:fontRef idx="minor">
+            <a:schemeClr val="lt1"/>
+          </a:fontRef>
+        </p:style>
+        <p:txBody>
+          <a:bodyPr rtlCol="0" anchor="ctr"/>
+          <a:lstStyle/>
+          <a:p>
+            <a:pPr algn="ctr"/>
+          </a:p>
+        </p:txBody>
+      </p:sp>
+      <p:sp>
+        <p:nvSpPr>
+          <p:cNvPr id="3" name="Rounded Rectangle 2"/>
+          <p:cNvSpPr/>
+          <p:nvPr/>
+        </p:nvSpPr>
+        <p:spPr>
+          <a:xfrm rot="1800000">
+            <a:off x="457200" y="457200"/>
+            <a:ext cx="1371600" cy="1371600"/>
+          </a:xfrm>
+          <a:prstGeom prst="roundRect">
+            <a:avLst/>
+          </a:prstGeom>
+          <a:solidFill>
+            <a:srgbClr val="3AFFD9"/>
+          </a:solidFill>
+          <a:ln>
+            <a:noFill/>
+          </a:ln>
+        </p:spPr>
+        <p:style>
+          <a:lnRef idx="1">
+            <a:schemeClr val="accent1"/>
+          </a:lnRef>
+          <a:fillRef idx="3">
+            <a:schemeClr val="accent1"/>
+          </a:fillRef>
+          <a:effectRef idx="2">
+            <a:schemeClr val="accent1"/>
+          </a:effectRef>
+          <a:fontRef idx="minor">
+            <a:schemeClr val="lt1"/>
+          </a:fontRef>
+        </p:style>
+        <p:txBody>
+          <a:bodyPr rtlCol="0" anchor="ctr"/>
+          <a:lstStyle/>
+          <a:p>
+            <a:pPr algn="ctr"/>
+          </a:p>
+        </p:txBody>
+      </p:sp>
+      <p:sp>
+        <p:nvSpPr>
+          <p:cNvPr id="4" name="Rounded Rectangle 3"/>
+          <p:cNvSpPr/>
+          <p:nvPr/>
+        </p:nvSpPr>
+        <p:spPr>
+          <a:xfrm rot="900000">
+            <a:off x="7315200" y="5029200"/>
+            <a:ext cx="1097280" cy="1097280"/>
+          </a:xfrm>
+          <a:prstGeom prst="roundRect">
+            <a:avLst/>
+          </a:prstGeom>
+          <a:solidFill>
+            <a:srgbClr val="FF4785"/>
+          </a:solidFill>
+          <a:ln>
+            <a:noFill/>
+          </a:ln>
+        </p:spPr>
+        <p:style>
+          <a:lnRef idx="1">
+            <a:schemeClr val="accent1"/>
+          </a:lnRef>
+          <a:fillRef idx="3">
+            <a:schemeClr val="accent1"/>
+          </a:fillRef>
+          <a:effectRef idx="2">
+            <a:schemeClr val="accent1"/>
+          </a:effectRef>
+          <a:fontRef idx="minor">
+            <a:schemeClr val="lt1"/>
+          </a:fontRef>
+        </p:style>
+        <p:txBody>
+          <a:bodyPr rtlCol="0" anchor="ctr"/>
+          <a:lstStyle/>
+          <a:p>
+            <a:pPr algn="ctr"/>
+          </a:p>
+        </p:txBody>
+      </p:sp>
+      <p:sp>
+        <p:nvSpPr>
+          <p:cNvPr id="5" name="Rounded Rectangle 4"/>
+          <p:cNvSpPr/>
+          <p:nvPr/>
+        </p:nvSpPr>
+        <p:spPr>
+          <a:xfrm rot="2700000">
+            <a:off x="1371600" y="5486400"/>
+            <a:ext cx="914400" cy="914400"/>
+          </a:xfrm>
+          <a:prstGeom prst="roundRect">
+            <a:avLst/>
+          </a:prstGeom>
+          <a:solidFill>
+            <a:srgbClr val="8A2BE2"/>
+          </a:solidFill>
+          <a:ln>
+            <a:noFill/>
+          </a:ln>
+        </p:spPr>
+        <p:style>
+          <a:lnRef idx="1">
+            <a:schemeClr val="accent1"/>
+          </a:lnRef>
+          <a:fillRef idx="3">
+            <a:schemeClr val="accent1"/>
+          </a:fillRef>
+          <a:effectRef idx="2">
+            <a:schemeClr val="accent1"/>
+          </a:effectRef>
+          <a:fontRef idx="minor">
+            <a:schemeClr val="lt1"/>
+          </a:fontRef>
+        </p:style>
+        <p:txBody>
+          <a:bodyPr rtlCol="0" anchor="ctr"/>
+          <a:lstStyle/>
+          <a:p>
+            <a:pPr algn="ctr"/>
+          </a:p>
+        </p:txBody>
+      </p:sp>
+      <p:sp>
+        <p:nvSpPr>
+          <p:cNvPr id="6" name="TextBox 5"/>
+          <p:cNvSpPr txBox="1"/>
+          <p:nvPr/>
+        </p:nvSpPr>
+        <p:spPr>
+          <a:xfrm>
+            <a:off x="914400" y="2286000"/>
+            <a:ext cx="7315200" cy="1828800"/>
+          </a:xfrm>
+          <a:prstGeom prst="rect">
+            <a:avLst/>
+          </a:prstGeom>
+          <a:noFill/>
+        </p:spPr>
+        <p:txBody>
+          <a:bodyPr wrap="square">
+            <a:spAutoFit/>
+          </a:bodyPr>
+          <a:lstStyle/>
+          <a:p>
+            <a:pPr algn="ctr">
+              <a:defRPr sz="5200" b="1">
+                <a:solidFill>
+                  <a:srgbClr val="FFFFFF"/>
+                </a:solidFill>
+              </a:defRPr>
+            </a:pPr>
+            <a:r>
+              <a:t>THANK YOU</a:t>
+            </a:r>
+          </a:p>
+          <a:p>
+            <a:br/>
+            <a:pPr algn="ctr">
+              <a:defRPr sz="2400">
+                <a:solidFill>
                   <a:srgbClr val="3AFFD9"/>
                 </a:solidFill>
               </a:defRPr>
             </a:pPr>
             <a:r>
-              <a:t>ENTERPRISE-GRADE SECURITY • INTELLIGENT RESPONSES</a:t>
+              <a:t>Enterprise-Ready AI Solution</a:t>
+            </a:r>
+          </a:p>
+        </p:txBody>
+      </p:sp>
+      <p:sp>
+        <p:nvSpPr>
+          <p:cNvPr id="7" name="TextBox 6"/>
+          <p:cNvSpPr txBox="1"/>
+          <p:nvPr/>
+        </p:nvSpPr>
+        <p:spPr>
+          <a:xfrm>
+            <a:off x="914400" y="4754880"/>
+            <a:ext cx="7315200" cy="1097280"/>
+          </a:xfrm>
+          <a:prstGeom prst="rect">
+            <a:avLst/>
+          </a:prstGeom>
+          <a:noFill/>
+        </p:spPr>
+        <p:txBody>
+          <a:bodyPr wrap="none">
+            <a:spAutoFit/>
+          </a:bodyPr>
+          <a:lstStyle/>
+          <a:p>
+            <a:pPr algn="ctr">
+              <a:defRPr sz="2000" b="1">
+                <a:solidFill>
+                  <a:srgbClr val="3AFFD9"/>
+                </a:solidFill>
+              </a:defRPr>
+            </a:pPr>
+            <a:r>
+              <a:t>THYNK UNLIMITED</a:t>
+            </a:r>
+          </a:p>
+          <a:p>
+            <a:pPr algn="ctr">
+              <a:defRPr sz="1400">
+                <a:solidFill>
+                  <a:srgbClr val="FFFFFF"/>
+                </a:solidFill>
+              </a:defRPr>
+            </a:pPr>
+            <a:r>
+              <a:t>WE LEARN FOR THE FUTURE</a:t>
+            </a:r>
+          </a:p>
+          <a:p>
+            <a:br/>
+            <a:pPr algn="ctr">
+              <a:defRPr sz="1200">
+                <a:solidFill>
+                  <a:srgbClr val="FFFFFF"/>
+                </a:solidFill>
+              </a:defRPr>
+            </a:pPr>
+            <a:r>
+              <a:t>Role-Based Access Chatbot • Secure • Intelligent • Scalable</a:t>
             </a:r>
           </a:p>
         </p:txBody>
@@ -3428,7 +7047,7 @@
             <a:pPr algn="ctr">
               <a:defRPr sz="3600" b="1">
                 <a:solidFill>
-                  <a:srgbClr val="4361EE"/>
+                  <a:srgbClr val="5856D6"/>
                 </a:solidFill>
               </a:defRPr>
             </a:pPr>
@@ -3569,7 +7188,7 @@
           </a:solidFill>
           <a:ln w="38100">
             <a:solidFill>
-              <a:srgbClr val="48BB78"/>
+              <a:srgbClr val="2ED573"/>
             </a:solidFill>
           </a:ln>
         </p:spPr>
@@ -3594,7 +7213,7 @@
             <a:pPr algn="ctr">
               <a:defRPr sz="2400" b="1">
                 <a:solidFill>
-                  <a:srgbClr val="48BB78"/>
+                  <a:srgbClr val="2ED573"/>
                 </a:solidFill>
               </a:defRPr>
             </a:pPr>
@@ -3748,7 +7367,7 @@
             <a:pPr algn="ctr">
               <a:defRPr sz="3600" b="1">
                 <a:solidFill>
-                  <a:srgbClr val="4361EE"/>
+                  <a:srgbClr val="5856D6"/>
                 </a:solidFill>
               </a:defRPr>
             </a:pPr>
@@ -3923,7 +7542,7 @@
           </a:solidFill>
           <a:ln w="25400">
             <a:solidFill>
-              <a:srgbClr val="4361EE"/>
+              <a:srgbClr val="5856D6"/>
             </a:solidFill>
           </a:ln>
         </p:spPr>
@@ -4005,7 +7624,7 @@
             <a:pPr>
               <a:defRPr sz="1800" b="1">
                 <a:solidFill>
-                  <a:srgbClr val="4361EE"/>
+                  <a:srgbClr val="5856D6"/>
                 </a:solidFill>
               </a:defRPr>
             </a:pPr>
@@ -4069,7 +7688,7 @@
           </a:solidFill>
           <a:ln w="25400">
             <a:solidFill>
-              <a:srgbClr val="48BB78"/>
+              <a:srgbClr val="2ED573"/>
             </a:solidFill>
           </a:ln>
         </p:spPr>
@@ -4151,7 +7770,7 @@
             <a:pPr>
               <a:defRPr sz="1800" b="1">
                 <a:solidFill>
-                  <a:srgbClr val="48BB78"/>
+                  <a:srgbClr val="2ED573"/>
                 </a:solidFill>
               </a:defRPr>
             </a:pPr>
@@ -4215,7 +7834,7 @@
           </a:solidFill>
           <a:ln w="25400">
             <a:solidFill>
-              <a:srgbClr val="ED8936"/>
+              <a:srgbClr val="FF8C00"/>
             </a:solidFill>
           </a:ln>
         </p:spPr>
@@ -4297,7 +7916,7 @@
             <a:pPr>
               <a:defRPr sz="1800" b="1">
                 <a:solidFill>
-                  <a:srgbClr val="ED8936"/>
+                  <a:srgbClr val="FF8C00"/>
                 </a:solidFill>
               </a:defRPr>
             </a:pPr>
@@ -4428,7 +8047,7 @@
             <a:pPr algn="ctr">
               <a:defRPr sz="3600" b="1">
                 <a:solidFill>
-                  <a:srgbClr val="4361EE"/>
+                  <a:srgbClr val="5856D6"/>
                 </a:solidFill>
               </a:defRPr>
             </a:pPr>
@@ -4453,7 +8072,7 @@
             <a:avLst/>
           </a:prstGeom>
           <a:solidFill>
-            <a:srgbClr val="4361EE"/>
+            <a:srgbClr val="5856D6"/>
           </a:solidFill>
           <a:ln>
             <a:noFill/>
@@ -4609,7 +8228,7 @@
             <a:avLst/>
           </a:prstGeom>
           <a:solidFill>
-            <a:srgbClr val="ED8936"/>
+            <a:srgbClr val="FF8C00"/>
           </a:solidFill>
           <a:ln>
             <a:noFill/>
@@ -4687,7 +8306,7 @@
             <a:avLst/>
           </a:prstGeom>
           <a:solidFill>
-            <a:srgbClr val="48BB78"/>
+            <a:srgbClr val="2ED573"/>
           </a:solidFill>
           <a:ln>
             <a:noFill/>
@@ -4765,7 +8384,7 @@
             <a:avLst/>
           </a:prstGeom>
           <a:solidFill>
-            <a:srgbClr val="4361EE"/>
+            <a:srgbClr val="5856D6"/>
           </a:solidFill>
           <a:ln>
             <a:noFill/>
@@ -5070,7 +8689,7 @@
             <a:pPr algn="ctr">
               <a:defRPr sz="3600" b="1">
                 <a:solidFill>
-                  <a:srgbClr val="4361EE"/>
+                  <a:srgbClr val="5856D6"/>
                 </a:solidFill>
               </a:defRPr>
             </a:pPr>
@@ -5099,7 +8718,7 @@
           </a:solidFill>
           <a:ln w="38100">
             <a:solidFill>
-              <a:srgbClr val="4361EE"/>
+              <a:srgbClr val="5856D6"/>
             </a:solidFill>
           </a:ln>
         </p:spPr>
@@ -5150,7 +8769,7 @@
             <a:pPr>
               <a:defRPr sz="2000" b="1">
                 <a:solidFill>
-                  <a:srgbClr val="4361EE"/>
+                  <a:srgbClr val="5856D6"/>
                 </a:solidFill>
               </a:defRPr>
             </a:pPr>
@@ -5412,7 +9031,7 @@
           </a:solidFill>
           <a:ln w="38100">
             <a:solidFill>
-              <a:srgbClr val="48BB78"/>
+              <a:srgbClr val="2ED573"/>
             </a:solidFill>
           </a:ln>
         </p:spPr>
@@ -5463,7 +9082,7 @@
             <a:pPr>
               <a:defRPr sz="2000" b="1">
                 <a:solidFill>
-                  <a:srgbClr val="48BB78"/>
+                  <a:srgbClr val="2ED573"/>
                 </a:solidFill>
               </a:defRPr>
             </a:pPr>
@@ -5561,7 +9180,7 @@
           </a:solidFill>
           <a:ln w="38100">
             <a:solidFill>
-              <a:srgbClr val="ED8936"/>
+              <a:srgbClr val="FF8C00"/>
             </a:solidFill>
           </a:ln>
         </p:spPr>
@@ -5612,7 +9231,7 @@
             <a:pPr>
               <a:defRPr sz="2000" b="1">
                 <a:solidFill>
-                  <a:srgbClr val="ED8936"/>
+                  <a:srgbClr val="FF8C00"/>
                 </a:solidFill>
               </a:defRPr>
             </a:pPr>
@@ -5777,7 +9396,7 @@
             <a:pPr algn="ctr">
               <a:defRPr sz="3600" b="1">
                 <a:solidFill>
-                  <a:srgbClr val="4361EE"/>
+                  <a:srgbClr val="5856D6"/>
                 </a:solidFill>
               </a:defRPr>
             </a:pPr>
@@ -5806,7 +9425,7 @@
           </a:solidFill>
           <a:ln w="25400">
             <a:solidFill>
-              <a:srgbClr val="48BB78"/>
+              <a:srgbClr val="2ED573"/>
             </a:solidFill>
           </a:ln>
         </p:spPr>
@@ -5857,7 +9476,7 @@
             <a:pPr>
               <a:defRPr sz="1600" b="1">
                 <a:solidFill>
-                  <a:srgbClr val="48BB78"/>
+                  <a:srgbClr val="2ED573"/>
                 </a:solidFill>
               </a:defRPr>
             </a:pPr>
@@ -6052,7 +9671,7 @@
           </a:solidFill>
           <a:ln w="25400">
             <a:solidFill>
-              <a:srgbClr val="ED8936"/>
+              <a:srgbClr val="FF8C00"/>
             </a:solidFill>
           </a:ln>
         </p:spPr>
@@ -6103,7 +9722,7 @@
             <a:pPr>
               <a:defRPr sz="1600" b="1">
                 <a:solidFill>
-                  <a:srgbClr val="ED8936"/>
+                  <a:srgbClr val="FF8C00"/>
                 </a:solidFill>
               </a:defRPr>
             </a:pPr>
@@ -6175,7 +9794,7 @@
           </a:solidFill>
           <a:ln w="25400">
             <a:solidFill>
-              <a:srgbClr val="4361EE"/>
+              <a:srgbClr val="5856D6"/>
             </a:solidFill>
           </a:ln>
         </p:spPr>
@@ -6226,7 +9845,7 @@
             <a:pPr>
               <a:defRPr sz="1600" b="1">
                 <a:solidFill>
-                  <a:srgbClr val="4361EE"/>
+                  <a:srgbClr val="5856D6"/>
                 </a:solidFill>
               </a:defRPr>
             </a:pPr>
@@ -6488,7 +10107,7 @@
             <a:pPr algn="ctr">
               <a:defRPr sz="3600" b="1">
                 <a:solidFill>
-                  <a:srgbClr val="4361EE"/>
+                  <a:srgbClr val="5856D6"/>
                 </a:solidFill>
               </a:defRPr>
             </a:pPr>
@@ -6513,7 +10132,7 @@
             <a:avLst/>
           </a:prstGeom>
           <a:solidFill>
-            <a:srgbClr val="48BB78"/>
+            <a:srgbClr val="2ED573"/>
           </a:solidFill>
           <a:ln>
             <a:noFill/>
@@ -6626,7 +10245,7 @@
             <a:avLst/>
           </a:prstGeom>
           <a:solidFill>
-            <a:srgbClr val="4361EE"/>
+            <a:srgbClr val="5856D6"/>
           </a:solidFill>
           <a:ln>
             <a:noFill/>
@@ -6739,7 +10358,7 @@
             <a:avLst/>
           </a:prstGeom>
           <a:solidFill>
-            <a:srgbClr val="ED8936"/>
+            <a:srgbClr val="FF8C00"/>
           </a:solidFill>
           <a:ln>
             <a:noFill/>
@@ -7036,7 +10655,7 @@
             <a:pPr algn="ctr">
               <a:defRPr sz="3600" b="1">
                 <a:solidFill>
-                  <a:srgbClr val="4361EE"/>
+                  <a:srgbClr val="5856D6"/>
                 </a:solidFill>
               </a:defRPr>
             </a:pPr>
@@ -7065,7 +10684,7 @@
           </a:solidFill>
           <a:ln w="25400">
             <a:solidFill>
-              <a:srgbClr val="4361EE"/>
+              <a:srgbClr val="5856D6"/>
             </a:solidFill>
           </a:ln>
         </p:spPr>
@@ -7116,7 +10735,7 @@
             <a:pPr>
               <a:defRPr sz="1400" b="1">
                 <a:solidFill>
-                  <a:srgbClr val="4361EE"/>
+                  <a:srgbClr val="5856D6"/>
                 </a:solidFill>
               </a:defRPr>
             </a:pPr>
@@ -7295,7 +10914,7 @@
           </a:solidFill>
           <a:ln w="25400">
             <a:solidFill>
-              <a:srgbClr val="ED8936"/>
+              <a:srgbClr val="FF8C00"/>
             </a:solidFill>
           </a:ln>
         </p:spPr>
@@ -7346,7 +10965,7 @@
             <a:pPr>
               <a:defRPr sz="1400" b="1">
                 <a:solidFill>
-                  <a:srgbClr val="ED8936"/>
+                  <a:srgbClr val="FF8C00"/>
                 </a:solidFill>
               </a:defRPr>
             </a:pPr>
@@ -7410,7 +11029,7 @@
           </a:solidFill>
           <a:ln w="25400">
             <a:solidFill>
-              <a:srgbClr val="48BB78"/>
+              <a:srgbClr val="2ED573"/>
             </a:solidFill>
           </a:ln>
         </p:spPr>
@@ -7461,7 +11080,7 @@
             <a:pPr>
               <a:defRPr sz="1400" b="1">
                 <a:solidFill>
-                  <a:srgbClr val="48BB78"/>
+                  <a:srgbClr val="2ED573"/>
                 </a:solidFill>
               </a:defRPr>
             </a:pPr>
@@ -7525,7 +11144,7 @@
           </a:solidFill>
           <a:ln w="25400">
             <a:solidFill>
-              <a:srgbClr val="4361EE"/>
+              <a:srgbClr val="5856D6"/>
             </a:solidFill>
           </a:ln>
         </p:spPr>
@@ -7576,7 +11195,7 @@
             <a:pPr>
               <a:defRPr sz="1400" b="1">
                 <a:solidFill>
-                  <a:srgbClr val="4361EE"/>
+                  <a:srgbClr val="5856D6"/>
                 </a:solidFill>
               </a:defRPr>
             </a:pPr>
@@ -7769,7 +11388,7 @@
             <a:avLst/>
           </a:prstGeom>
           <a:solidFill>
-            <a:srgbClr val="1A202C"/>
+            <a:srgbClr val="FFFFFF"/>
           </a:solidFill>
           <a:ln>
             <a:noFill/>
@@ -7799,20 +11418,55 @@
       </p:sp>
       <p:sp>
         <p:nvSpPr>
-          <p:cNvPr id="3" name="Rounded Rectangle 2"/>
+          <p:cNvPr id="3" name="TextBox 2"/>
+          <p:cNvSpPr txBox="1"/>
+          <p:nvPr/>
+        </p:nvSpPr>
+        <p:spPr>
+          <a:xfrm>
+            <a:off x="914400" y="457200"/>
+            <a:ext cx="7315200" cy="731520"/>
+          </a:xfrm>
+          <a:prstGeom prst="rect">
+            <a:avLst/>
+          </a:prstGeom>
+          <a:noFill/>
+        </p:spPr>
+        <p:txBody>
+          <a:bodyPr wrap="none">
+            <a:spAutoFit/>
+          </a:bodyPr>
+          <a:lstStyle/>
+          <a:p>
+            <a:pPr algn="ctr">
+              <a:defRPr sz="3600" b="1">
+                <a:solidFill>
+                  <a:srgbClr val="8A2BE2"/>
+                </a:solidFill>
+              </a:defRPr>
+            </a:pPr>
+            <a:r>
+              <a:t>VECTOR DATABASE - CHROMADB</a:t>
+            </a:r>
+          </a:p>
+        </p:txBody>
+      </p:sp>
+      <p:sp>
+        <p:nvSpPr>
+          <p:cNvPr id="4" name="Rounded Rectangle 3"/>
           <p:cNvSpPr/>
           <p:nvPr/>
         </p:nvSpPr>
         <p:spPr>
-          <a:xfrm rot="1800000">
-            <a:off x="457200" y="457200"/>
-            <a:ext cx="1371600" cy="1371600"/>
+          <a:xfrm>
+            <a:off x="1371600" y="1828800"/>
+            <a:ext cx="2011680" cy="1371600"/>
           </a:xfrm>
           <a:prstGeom prst="roundRect">
             <a:avLst/>
           </a:prstGeom>
           <a:solidFill>
-            <a:srgbClr val="3AFFD9"/>
+            <a:srgbClr val="5856D6"/>
           </a:solidFill>
           <a:ln>
             <a:noFill/>
@@ -7842,14 +11496,84 @@
       </p:sp>
       <p:sp>
         <p:nvSpPr>
-          <p:cNvPr id="4" name="Rounded Rectangle 3"/>
+          <p:cNvPr id="5" name="TextBox 4"/>
+          <p:cNvSpPr txBox="1"/>
+          <p:nvPr/>
+        </p:nvSpPr>
+        <p:spPr>
+          <a:xfrm>
+            <a:off x="1371600" y="2011680"/>
+            <a:ext cx="2011680" cy="548640"/>
+          </a:xfrm>
+          <a:prstGeom prst="rect">
+            <a:avLst/>
+          </a:prstGeom>
+          <a:noFill/>
+        </p:spPr>
+        <p:txBody>
+          <a:bodyPr wrap="none" anchor="ctr">
+            <a:spAutoFit/>
+          </a:bodyPr>
+          <a:lstStyle/>
+          <a:p>
+            <a:pPr algn="ctr">
+              <a:defRPr sz="4000" b="1">
+                <a:solidFill>
+                  <a:srgbClr val="FFFFFF"/>
+                </a:solidFill>
+              </a:defRPr>
+            </a:pPr>
+            <a:r>
+              <a:t>135</a:t>
+            </a:r>
+          </a:p>
+        </p:txBody>
+      </p:sp>
+      <p:sp>
+        <p:nvSpPr>
+          <p:cNvPr id="6" name="TextBox 5"/>
+          <p:cNvSpPr txBox="1"/>
+          <p:nvPr/>
+        </p:nvSpPr>
+        <p:spPr>
+          <a:xfrm>
+            <a:off x="1371600" y="2651760"/>
+            <a:ext cx="2011680" cy="365760"/>
+          </a:xfrm>
+          <a:prstGeom prst="rect">
+            <a:avLst/>
+          </a:prstGeom>
+          <a:noFill/>
+        </p:spPr>
+        <p:txBody>
+          <a:bodyPr wrap="none">
+            <a:spAutoFit/>
+          </a:bodyPr>
+          <a:lstStyle/>
+          <a:p>
+            <a:pPr algn="ctr">
+              <a:defRPr sz="1400">
+                <a:solidFill>
+                  <a:srgbClr val="FFFFFF"/>
+                </a:solidFill>
+              </a:defRPr>
+            </a:pPr>
+            <a:r>
+              <a:t>Indexed Documents</a:t>
+            </a:r>
+          </a:p>
+        </p:txBody>
+      </p:sp>
+      <p:sp>
+        <p:nvSpPr>
+          <p:cNvPr id="7" name="Rounded Rectangle 6"/>
           <p:cNvSpPr/>
           <p:nvPr/>
         </p:nvSpPr>
         <p:spPr>
-          <a:xfrm rot="900000">
-            <a:off x="7315200" y="5029200"/>
-            <a:ext cx="1097280" cy="1097280"/>
+          <a:xfrm>
+            <a:off x="3657600" y="1828800"/>
+            <a:ext cx="2011680" cy="1371600"/>
           </a:xfrm>
           <a:prstGeom prst="roundRect">
             <a:avLst/>
@@ -7885,62 +11609,49 @@
       </p:sp>
       <p:sp>
         <p:nvSpPr>
-          <p:cNvPr id="5" name="TextBox 4"/>
-          <p:cNvSpPr txBox="1"/>
-          <p:nvPr/>
-        </p:nvSpPr>
-        <p:spPr>
-          <a:xfrm>
-            <a:off x="914400" y="2286000"/>
-            <a:ext cx="7315200" cy="1828800"/>
-          </a:xfrm>
-          <a:prstGeom prst="rect">
-            <a:avLst/>
-          </a:prstGeom>
-          <a:noFill/>
-        </p:spPr>
-        <p:txBody>
-          <a:bodyPr wrap="square">
+          <p:cNvPr id="8" name="TextBox 7"/>
+          <p:cNvSpPr txBox="1"/>
+          <p:nvPr/>
+        </p:nvSpPr>
+        <p:spPr>
+          <a:xfrm>
+            <a:off x="3657600" y="2011680"/>
+            <a:ext cx="2011680" cy="548640"/>
+          </a:xfrm>
+          <a:prstGeom prst="rect">
+            <a:avLst/>
+          </a:prstGeom>
+          <a:noFill/>
+        </p:spPr>
+        <p:txBody>
+          <a:bodyPr wrap="none" anchor="ctr">
             <a:spAutoFit/>
           </a:bodyPr>
           <a:lstStyle/>
           <a:p>
             <a:pPr algn="ctr">
-              <a:defRPr sz="5200" b="1">
+              <a:defRPr sz="4000" b="1">
                 <a:solidFill>
                   <a:srgbClr val="FFFFFF"/>
                 </a:solidFill>
               </a:defRPr>
             </a:pPr>
             <a:r>
-              <a:t>THANK YOU</a:t>
-            </a:r>
-          </a:p>
-          <a:p>
-            <a:br/>
-            <a:pPr algn="ctr">
-              <a:defRPr sz="2400">
-                <a:solidFill>
-                  <a:srgbClr val="3AFFD9"/>
-                </a:solidFill>
-              </a:defRPr>
-            </a:pPr>
-            <a:r>
-              <a:t>Enterprise-Ready AI Solution</a:t>
-            </a:r>
-          </a:p>
-        </p:txBody>
-      </p:sp>
-      <p:sp>
-        <p:nvSpPr>
-          <p:cNvPr id="6" name="TextBox 5"/>
-          <p:cNvSpPr txBox="1"/>
-          <p:nvPr/>
-        </p:nvSpPr>
-        <p:spPr>
-          <a:xfrm>
-            <a:off x="914400" y="5029200"/>
-            <a:ext cx="7315200" cy="914400"/>
+              <a:t>384</a:t>
+            </a:r>
+          </a:p>
+        </p:txBody>
+      </p:sp>
+      <p:sp>
+        <p:nvSpPr>
+          <p:cNvPr id="9" name="TextBox 8"/>
+          <p:cNvSpPr txBox="1"/>
+          <p:nvPr/>
+        </p:nvSpPr>
+        <p:spPr>
+          <a:xfrm>
+            <a:off x="3657600" y="2651760"/>
+            <a:ext cx="2011680" cy="365760"/>
           </a:xfrm>
           <a:prstGeom prst="rect">
             <a:avLst/>
@@ -7952,28 +11663,242 @@
             <a:spAutoFit/>
           </a:bodyPr>
           <a:lstStyle/>
-          <a:p>
-            <a:pPr algn="ctr">
-              <a:defRPr sz="1600">
-                <a:solidFill>
-                  <a:srgbClr val="FFFFFF"/>
-                </a:solidFill>
-              </a:defRPr>
-            </a:pPr>
-            <a:r>
-              <a:t>Role-Based Access Chatbot with RAG Pipeline</a:t>
-            </a:r>
-          </a:p>
           <a:p>
             <a:pPr algn="ctr">
               <a:defRPr sz="1400">
                 <a:solidFill>
-                  <a:srgbClr val="3AFFD9"/>
-                </a:solidFill>
-              </a:defRPr>
-            </a:pPr>
-            <a:r>
-              <a:t>Secure • Intelligent • Scalable</a:t>
+                  <a:srgbClr val="FFFFFF"/>
+                </a:solidFill>
+              </a:defRPr>
+            </a:pPr>
+            <a:r>
+              <a:t>Embedding Dimensions</a:t>
+            </a:r>
+          </a:p>
+        </p:txBody>
+      </p:sp>
+      <p:sp>
+        <p:nvSpPr>
+          <p:cNvPr id="10" name="Rounded Rectangle 9"/>
+          <p:cNvSpPr/>
+          <p:nvPr/>
+        </p:nvSpPr>
+        <p:spPr>
+          <a:xfrm>
+            <a:off x="5943600" y="1828800"/>
+            <a:ext cx="2011680" cy="1371600"/>
+          </a:xfrm>
+          <a:prstGeom prst="roundRect">
+            <a:avLst/>
+          </a:prstGeom>
+          <a:solidFill>
+            <a:srgbClr val="2ED573"/>
+          </a:solidFill>
+          <a:ln>
+            <a:noFill/>
+          </a:ln>
+        </p:spPr>
+        <p:style>
+          <a:lnRef idx="1">
+            <a:schemeClr val="accent1"/>
+          </a:lnRef>
+          <a:fillRef idx="3">
+            <a:schemeClr val="accent1"/>
+          </a:fillRef>
+          <a:effectRef idx="2">
+            <a:schemeClr val="accent1"/>
+          </a:effectRef>
+          <a:fontRef idx="minor">
+            <a:schemeClr val="lt1"/>
+          </a:fontRef>
+        </p:style>
+        <p:txBody>
+          <a:bodyPr rtlCol="0" anchor="ctr"/>
+          <a:lstStyle/>
+          <a:p>
+            <a:pPr algn="ctr"/>
+          </a:p>
+        </p:txBody>
+      </p:sp>
+      <p:sp>
+        <p:nvSpPr>
+          <p:cNvPr id="11" name="TextBox 10"/>
+          <p:cNvSpPr txBox="1"/>
+          <p:nvPr/>
+        </p:nvSpPr>
+        <p:spPr>
+          <a:xfrm>
+            <a:off x="5943600" y="2011680"/>
+            <a:ext cx="2011680" cy="548640"/>
+          </a:xfrm>
+          <a:prstGeom prst="rect">
+            <a:avLst/>
+          </a:prstGeom>
+          <a:noFill/>
+        </p:spPr>
+        <p:txBody>
+          <a:bodyPr wrap="none" anchor="ctr">
+            <a:spAutoFit/>
+          </a:bodyPr>
+          <a:lstStyle/>
+          <a:p>
+            <a:pPr algn="ctr">
+              <a:defRPr sz="4000" b="1">
+                <a:solidFill>
+                  <a:srgbClr val="FFFFFF"/>
+                </a:solidFill>
+              </a:defRPr>
+            </a:pPr>
+            <a:r>
+              <a:t>~20ms</a:t>
+            </a:r>
+          </a:p>
+        </p:txBody>
+      </p:sp>
+      <p:sp>
+        <p:nvSpPr>
+          <p:cNvPr id="12" name="TextBox 11"/>
+          <p:cNvSpPr txBox="1"/>
+          <p:nvPr/>
+        </p:nvSpPr>
+        <p:spPr>
+          <a:xfrm>
+            <a:off x="5943600" y="2651760"/>
+            <a:ext cx="2011680" cy="365760"/>
+          </a:xfrm>
+          <a:prstGeom prst="rect">
+            <a:avLst/>
+          </a:prstGeom>
+          <a:noFill/>
+        </p:spPr>
+        <p:txBody>
+          <a:bodyPr wrap="none">
+            <a:spAutoFit/>
+          </a:bodyPr>
+          <a:lstStyle/>
+          <a:p>
+            <a:pPr algn="ctr">
+              <a:defRPr sz="1400">
+                <a:solidFill>
+                  <a:srgbClr val="FFFFFF"/>
+                </a:solidFill>
+              </a:defRPr>
+            </a:pPr>
+            <a:r>
+              <a:t>Search Speed</a:t>
+            </a:r>
+          </a:p>
+        </p:txBody>
+      </p:sp>
+      <p:sp>
+        <p:nvSpPr>
+          <p:cNvPr id="13" name="TextBox 12"/>
+          <p:cNvSpPr txBox="1"/>
+          <p:nvPr/>
+        </p:nvSpPr>
+        <p:spPr>
+          <a:xfrm>
+            <a:off x="1371600" y="3657600"/>
+            <a:ext cx="6400800" cy="2286000"/>
+          </a:xfrm>
+          <a:prstGeom prst="rect">
+            <a:avLst/>
+          </a:prstGeom>
+          <a:noFill/>
+        </p:spPr>
+        <p:txBody>
+          <a:bodyPr wrap="square">
+            <a:spAutoFit/>
+          </a:bodyPr>
+          <a:lstStyle/>
+          <a:p>
+            <a:pPr>
+              <a:spcAft>
+                <a:spcPts val="1000"/>
+              </a:spcAft>
+              <a:defRPr sz="2000" b="1">
+                <a:solidFill>
+                  <a:srgbClr val="8A2BE2"/>
+                </a:solidFill>
+              </a:defRPr>
+            </a:pPr>
+            <a:r>
+              <a:t>Key Features:</a:t>
+            </a:r>
+          </a:p>
+          <a:p>
+            <a:pPr>
+              <a:spcAft>
+                <a:spcPts val="800"/>
+              </a:spcAft>
+              <a:defRPr sz="1400">
+                <a:solidFill>
+                  <a:srgbClr val="2D3748"/>
+                </a:solidFill>
+              </a:defRPr>
+            </a:pPr>
+            <a:r>
+              <a:t>• Semantic similarity search with cosine distance</a:t>
+            </a:r>
+          </a:p>
+          <a:p>
+            <a:pPr>
+              <a:spcAft>
+                <a:spcPts val="800"/>
+              </a:spcAft>
+              <a:defRPr sz="1400">
+                <a:solidFill>
+                  <a:srgbClr val="2D3748"/>
+                </a:solidFill>
+              </a:defRPr>
+            </a:pPr>
+            <a:r>
+              <a:t>• Normalized embeddings using MiniLM-L6-v2 model</a:t>
+            </a:r>
+          </a:p>
+          <a:p>
+            <a:pPr>
+              <a:spcAft>
+                <a:spcPts val="800"/>
+              </a:spcAft>
+              <a:defRPr sz="1400">
+                <a:solidFill>
+                  <a:srgbClr val="2D3748"/>
+                </a:solidFill>
+              </a:defRPr>
+            </a:pPr>
+            <a:r>
+              <a:t>• Efficient metadata filtering for RBAC</a:t>
+            </a:r>
+          </a:p>
+          <a:p>
+            <a:pPr>
+              <a:spcAft>
+                <a:spcPts val="800"/>
+              </a:spcAft>
+              <a:defRPr sz="1400">
+                <a:solidFill>
+                  <a:srgbClr val="2D3748"/>
+                </a:solidFill>
+              </a:defRPr>
+            </a:pPr>
+            <a:r>
+              <a:t>• Persistent storage with automatic indexing</a:t>
+            </a:r>
+          </a:p>
+          <a:p>
+            <a:pPr>
+              <a:spcAft>
+                <a:spcPts val="800"/>
+              </a:spcAft>
+              <a:defRPr sz="1400">
+                <a:solidFill>
+                  <a:srgbClr val="2D3748"/>
+                </a:solidFill>
+              </a:defRPr>
+            </a:pPr>
+            <a:r>
+              <a:t>• Support for multi-modal document types (CSV, Markdown)</a:t>
             </a:r>
           </a:p>
         </p:txBody>

</xml_diff>